<commit_message>
fix: full 33-slide review — all MUST FIX resolved
S1-S8: transparent KNU logo, 9pt→11pt fonts, S4 overlap fixed,
       S7 duplicate text removed, S2/S3 description 11→13pt
S9-S16: S10 footnote 10pt, S11/S12 method names 10pt,
        S14 MCC descriptions 10pt, S13 layer card colors
S17-S25: S18 overlap fixed, S21 ANOVA label corrected,
         S17-S25 body text 11→12pt, S20 card symmetry
S26-S33: bar overflow fixed (capped at 3.5"), labels inside bars,
         S31 text 12pt, S29 references 10pt

All 33 slides verified: no overlaps, no off-screen elements,
minimum font 10pt throughout.

Co-Authored-By: Claude Opus 4.6 (1M context) <noreply@anthropic.com>
</commit_message>
<xml_diff>
--- a/paper/ppt/MutBench_Defense_v4.pptx
+++ b/paper/ppt/MutBench_Defense_v4.pptx
@@ -3165,7 +3165,7 @@
       </p:sp>
       <p:pic>
         <p:nvPicPr>
-          <p:cNvPr id="3" name="Picture 2" descr="knu_emblem_official.jpg"/>
+          <p:cNvPr id="3" name="Picture 2" descr="knu_symbol_t.png"/>
           <p:cNvPicPr>
             <a:picLocks noChangeAspect="1"/>
           </p:cNvPicPr>
@@ -3476,7 +3476,7 @@
       </p:sp>
       <p:pic>
         <p:nvPicPr>
-          <p:cNvPr id="4" name="Picture 3" descr="knu_emblem_official.jpg"/>
+          <p:cNvPr id="4" name="Picture 3" descr="knu_symbol_t.png"/>
           <p:cNvPicPr>
             <a:picLocks noChangeAspect="1"/>
           </p:cNvPicPr>
@@ -5420,7 +5420,7 @@
           <a:lstStyle/>
           <a:p>
             <a:pPr algn="ctr">
-              <a:defRPr sz="900" b="0">
+              <a:defRPr sz="1000" b="0">
                 <a:solidFill>
                   <a:srgbClr val="888888"/>
                 </a:solidFill>
@@ -5530,7 +5530,7 @@
       </p:sp>
       <p:pic>
         <p:nvPicPr>
-          <p:cNvPr id="4" name="Picture 3" descr="knu_emblem_official.jpg"/>
+          <p:cNvPr id="4" name="Picture 3" descr="knu_symbol_t.png"/>
           <p:cNvPicPr>
             <a:picLocks noChangeAspect="1"/>
           </p:cNvPicPr>
@@ -6327,7 +6327,7 @@
           <a:lstStyle/>
           <a:p>
             <a:pPr algn="l">
-              <a:defRPr sz="900" b="1">
+              <a:defRPr sz="1000" b="1">
                 <a:solidFill>
                   <a:srgbClr val="0D7377"/>
                 </a:solidFill>
@@ -6361,7 +6361,7 @@
           <a:lstStyle/>
           <a:p>
             <a:pPr algn="l">
-              <a:defRPr sz="800" b="0">
+              <a:defRPr sz="1000" b="0">
                 <a:solidFill>
                   <a:srgbClr val="888888"/>
                 </a:solidFill>
@@ -6395,7 +6395,7 @@
           <a:lstStyle/>
           <a:p>
             <a:pPr algn="l">
-              <a:defRPr sz="900" b="1">
+              <a:defRPr sz="1000" b="1">
                 <a:solidFill>
                   <a:srgbClr val="0D7377"/>
                 </a:solidFill>
@@ -6429,7 +6429,7 @@
           <a:lstStyle/>
           <a:p>
             <a:pPr algn="l">
-              <a:defRPr sz="800" b="0">
+              <a:defRPr sz="1000" b="0">
                 <a:solidFill>
                   <a:srgbClr val="888888"/>
                 </a:solidFill>
@@ -6463,7 +6463,7 @@
           <a:lstStyle/>
           <a:p>
             <a:pPr algn="l">
-              <a:defRPr sz="900" b="1">
+              <a:defRPr sz="1000" b="1">
                 <a:solidFill>
                   <a:srgbClr val="0D7377"/>
                 </a:solidFill>
@@ -6497,7 +6497,7 @@
           <a:lstStyle/>
           <a:p>
             <a:pPr algn="l">
-              <a:defRPr sz="800" b="0">
+              <a:defRPr sz="1000" b="0">
                 <a:solidFill>
                   <a:srgbClr val="888888"/>
                 </a:solidFill>
@@ -6531,7 +6531,7 @@
           <a:lstStyle/>
           <a:p>
             <a:pPr algn="l">
-              <a:defRPr sz="900" b="1">
+              <a:defRPr sz="1000" b="1">
                 <a:solidFill>
                   <a:srgbClr val="0D7377"/>
                 </a:solidFill>
@@ -6565,7 +6565,7 @@
           <a:lstStyle/>
           <a:p>
             <a:pPr algn="l">
-              <a:defRPr sz="800" b="0">
+              <a:defRPr sz="1000" b="0">
                 <a:solidFill>
                   <a:srgbClr val="888888"/>
                 </a:solidFill>
@@ -6599,7 +6599,7 @@
           <a:lstStyle/>
           <a:p>
             <a:pPr algn="l">
-              <a:defRPr sz="900" b="1">
+              <a:defRPr sz="1000" b="1">
                 <a:solidFill>
                   <a:srgbClr val="0D7377"/>
                 </a:solidFill>
@@ -6633,7 +6633,7 @@
           <a:lstStyle/>
           <a:p>
             <a:pPr algn="l">
-              <a:defRPr sz="800" b="0">
+              <a:defRPr sz="1000" b="0">
                 <a:solidFill>
                   <a:srgbClr val="888888"/>
                 </a:solidFill>
@@ -6667,7 +6667,7 @@
           <a:lstStyle/>
           <a:p>
             <a:pPr algn="l">
-              <a:defRPr sz="900" b="1">
+              <a:defRPr sz="1000" b="1">
                 <a:solidFill>
                   <a:srgbClr val="0D7377"/>
                 </a:solidFill>
@@ -6701,7 +6701,7 @@
           <a:lstStyle/>
           <a:p>
             <a:pPr algn="l">
-              <a:defRPr sz="800" b="0">
+              <a:defRPr sz="1000" b="0">
                 <a:solidFill>
                   <a:srgbClr val="888888"/>
                 </a:solidFill>
@@ -6735,7 +6735,7 @@
           <a:lstStyle/>
           <a:p>
             <a:pPr algn="l">
-              <a:defRPr sz="900" b="1">
+              <a:defRPr sz="1000" b="1">
                 <a:solidFill>
                   <a:srgbClr val="0D7377"/>
                 </a:solidFill>
@@ -6769,7 +6769,7 @@
           <a:lstStyle/>
           <a:p>
             <a:pPr algn="l">
-              <a:defRPr sz="800" b="0">
+              <a:defRPr sz="1000" b="0">
                 <a:solidFill>
                   <a:srgbClr val="888888"/>
                 </a:solidFill>
@@ -6803,7 +6803,7 @@
           <a:lstStyle/>
           <a:p>
             <a:pPr algn="l">
-              <a:defRPr sz="900" b="1">
+              <a:defRPr sz="1000" b="1">
                 <a:solidFill>
                   <a:srgbClr val="0D7377"/>
                 </a:solidFill>
@@ -6837,7 +6837,7 @@
           <a:lstStyle/>
           <a:p>
             <a:pPr algn="l">
-              <a:defRPr sz="800" b="0">
+              <a:defRPr sz="1000" b="0">
                 <a:solidFill>
                   <a:srgbClr val="888888"/>
                 </a:solidFill>
@@ -6871,7 +6871,7 @@
           <a:lstStyle/>
           <a:p>
             <a:pPr algn="l">
-              <a:defRPr sz="900" b="1">
+              <a:defRPr sz="1000" b="1">
                 <a:solidFill>
                   <a:srgbClr val="0D7377"/>
                 </a:solidFill>
@@ -6905,7 +6905,7 @@
           <a:lstStyle/>
           <a:p>
             <a:pPr algn="l">
-              <a:defRPr sz="800" b="0">
+              <a:defRPr sz="1000" b="0">
                 <a:solidFill>
                   <a:srgbClr val="888888"/>
                 </a:solidFill>
@@ -7016,7 +7016,7 @@
           <a:lstStyle/>
           <a:p>
             <a:pPr algn="l">
-              <a:defRPr sz="900" b="1">
+              <a:defRPr sz="1000" b="1">
                 <a:solidFill>
                   <a:srgbClr val="2E7D32"/>
                 </a:solidFill>
@@ -7050,7 +7050,7 @@
           <a:lstStyle/>
           <a:p>
             <a:pPr algn="l">
-              <a:defRPr sz="800" b="0">
+              <a:defRPr sz="1000" b="0">
                 <a:solidFill>
                   <a:srgbClr val="888888"/>
                 </a:solidFill>
@@ -7084,7 +7084,7 @@
           <a:lstStyle/>
           <a:p>
             <a:pPr algn="l">
-              <a:defRPr sz="900" b="1">
+              <a:defRPr sz="1000" b="1">
                 <a:solidFill>
                   <a:srgbClr val="2E7D32"/>
                 </a:solidFill>
@@ -7118,7 +7118,7 @@
           <a:lstStyle/>
           <a:p>
             <a:pPr algn="l">
-              <a:defRPr sz="800" b="0">
+              <a:defRPr sz="1000" b="0">
                 <a:solidFill>
                   <a:srgbClr val="888888"/>
                 </a:solidFill>
@@ -7152,7 +7152,7 @@
           <a:lstStyle/>
           <a:p>
             <a:pPr algn="l">
-              <a:defRPr sz="900" b="1">
+              <a:defRPr sz="1000" b="1">
                 <a:solidFill>
                   <a:srgbClr val="2E7D32"/>
                 </a:solidFill>
@@ -7186,7 +7186,7 @@
           <a:lstStyle/>
           <a:p>
             <a:pPr algn="l">
-              <a:defRPr sz="800" b="0">
+              <a:defRPr sz="1000" b="0">
                 <a:solidFill>
                   <a:srgbClr val="888888"/>
                 </a:solidFill>
@@ -7220,7 +7220,7 @@
           <a:lstStyle/>
           <a:p>
             <a:pPr algn="l">
-              <a:defRPr sz="900" b="1">
+              <a:defRPr sz="1000" b="1">
                 <a:solidFill>
                   <a:srgbClr val="2E7D32"/>
                 </a:solidFill>
@@ -7254,7 +7254,7 @@
           <a:lstStyle/>
           <a:p>
             <a:pPr algn="l">
-              <a:defRPr sz="800" b="0">
+              <a:defRPr sz="1000" b="0">
                 <a:solidFill>
                   <a:srgbClr val="888888"/>
                 </a:solidFill>
@@ -7288,7 +7288,7 @@
           <a:lstStyle/>
           <a:p>
             <a:pPr algn="l">
-              <a:defRPr sz="900" b="1">
+              <a:defRPr sz="1000" b="1">
                 <a:solidFill>
                   <a:srgbClr val="2E7D32"/>
                 </a:solidFill>
@@ -7322,7 +7322,7 @@
           <a:lstStyle/>
           <a:p>
             <a:pPr algn="l">
-              <a:defRPr sz="800" b="0">
+              <a:defRPr sz="1000" b="0">
                 <a:solidFill>
                   <a:srgbClr val="888888"/>
                 </a:solidFill>
@@ -7356,7 +7356,7 @@
           <a:lstStyle/>
           <a:p>
             <a:pPr algn="l">
-              <a:defRPr sz="900" b="1">
+              <a:defRPr sz="1000" b="1">
                 <a:solidFill>
                   <a:srgbClr val="2E7D32"/>
                 </a:solidFill>
@@ -7390,7 +7390,7 @@
           <a:lstStyle/>
           <a:p>
             <a:pPr algn="l">
-              <a:defRPr sz="800" b="0">
+              <a:defRPr sz="1000" b="0">
                 <a:solidFill>
                   <a:srgbClr val="888888"/>
                 </a:solidFill>
@@ -7424,7 +7424,7 @@
           <a:lstStyle/>
           <a:p>
             <a:pPr algn="l">
-              <a:defRPr sz="900" b="1">
+              <a:defRPr sz="1000" b="1">
                 <a:solidFill>
                   <a:srgbClr val="2E7D32"/>
                 </a:solidFill>
@@ -7458,7 +7458,7 @@
           <a:lstStyle/>
           <a:p>
             <a:pPr algn="l">
-              <a:defRPr sz="800" b="0">
+              <a:defRPr sz="1000" b="0">
                 <a:solidFill>
                   <a:srgbClr val="888888"/>
                 </a:solidFill>
@@ -7492,7 +7492,7 @@
           <a:lstStyle/>
           <a:p>
             <a:pPr algn="l">
-              <a:defRPr sz="900" b="1">
+              <a:defRPr sz="1000" b="1">
                 <a:solidFill>
                   <a:srgbClr val="2E7D32"/>
                 </a:solidFill>
@@ -7526,7 +7526,7 @@
           <a:lstStyle/>
           <a:p>
             <a:pPr algn="l">
-              <a:defRPr sz="800" b="0">
+              <a:defRPr sz="1000" b="0">
                 <a:solidFill>
                   <a:srgbClr val="888888"/>
                 </a:solidFill>
@@ -7560,7 +7560,7 @@
           <a:lstStyle/>
           <a:p>
             <a:pPr algn="l">
-              <a:defRPr sz="900" b="1">
+              <a:defRPr sz="1000" b="1">
                 <a:solidFill>
                   <a:srgbClr val="2E7D32"/>
                 </a:solidFill>
@@ -7594,7 +7594,7 @@
           <a:lstStyle/>
           <a:p>
             <a:pPr algn="l">
-              <a:defRPr sz="800" b="0">
+              <a:defRPr sz="1000" b="0">
                 <a:solidFill>
                   <a:srgbClr val="888888"/>
                 </a:solidFill>
@@ -7628,7 +7628,7 @@
           <a:lstStyle/>
           <a:p>
             <a:pPr algn="l">
-              <a:defRPr sz="900" b="1">
+              <a:defRPr sz="1000" b="1">
                 <a:solidFill>
                   <a:srgbClr val="2E7D32"/>
                 </a:solidFill>
@@ -7662,7 +7662,7 @@
           <a:lstStyle/>
           <a:p>
             <a:pPr algn="l">
-              <a:defRPr sz="800" b="0">
+              <a:defRPr sz="1000" b="0">
                 <a:solidFill>
                   <a:srgbClr val="888888"/>
                 </a:solidFill>
@@ -7696,7 +7696,7 @@
           <a:lstStyle/>
           <a:p>
             <a:pPr algn="l">
-              <a:defRPr sz="900" b="1">
+              <a:defRPr sz="1000" b="1">
                 <a:solidFill>
                   <a:srgbClr val="2E7D32"/>
                 </a:solidFill>
@@ -7730,7 +7730,7 @@
           <a:lstStyle/>
           <a:p>
             <a:pPr algn="l">
-              <a:defRPr sz="800" b="0">
+              <a:defRPr sz="1000" b="0">
                 <a:solidFill>
                   <a:srgbClr val="888888"/>
                 </a:solidFill>
@@ -7764,7 +7764,7 @@
           <a:lstStyle/>
           <a:p>
             <a:pPr algn="l">
-              <a:defRPr sz="900" b="1">
+              <a:defRPr sz="1000" b="1">
                 <a:solidFill>
                   <a:srgbClr val="2E7D32"/>
                 </a:solidFill>
@@ -7798,7 +7798,7 @@
           <a:lstStyle/>
           <a:p>
             <a:pPr algn="l">
-              <a:defRPr sz="800" b="0">
+              <a:defRPr sz="1000" b="0">
                 <a:solidFill>
                   <a:srgbClr val="888888"/>
                 </a:solidFill>
@@ -7819,7 +7819,7 @@
         </p:nvSpPr>
         <p:spPr>
           <a:xfrm>
-            <a:off x="3200400" y="5029200"/>
+            <a:off x="3200400" y="5303520"/>
             <a:ext cx="5760720" cy="365760"/>
           </a:xfrm>
           <a:prstGeom prst="rect">
@@ -7942,7 +7942,7 @@
       </p:sp>
       <p:pic>
         <p:nvPicPr>
-          <p:cNvPr id="4" name="Picture 3" descr="knu_emblem_official.jpg"/>
+          <p:cNvPr id="4" name="Picture 3" descr="knu_symbol_t.png"/>
           <p:cNvPicPr>
             <a:picLocks noChangeAspect="1"/>
           </p:cNvPicPr>
@@ -8239,7 +8239,7 @@
           <a:lstStyle/>
           <a:p>
             <a:pPr algn="ctr">
-              <a:defRPr sz="900" b="0">
+              <a:defRPr sz="1000" b="0">
                 <a:solidFill>
                   <a:srgbClr val="1B2A4A"/>
                 </a:solidFill>
@@ -8273,7 +8273,7 @@
           <a:lstStyle/>
           <a:p>
             <a:pPr algn="l">
-              <a:defRPr sz="900" b="0">
+              <a:defRPr sz="1000" b="0">
                 <a:solidFill>
                   <a:srgbClr val="333333"/>
                 </a:solidFill>
@@ -8286,7 +8286,7 @@
           </a:p>
           <a:p>
             <a:pPr algn="l">
-              <a:defRPr sz="900" b="0">
+              <a:defRPr sz="1000" b="0">
                 <a:solidFill>
                   <a:srgbClr val="333333"/>
                 </a:solidFill>
@@ -8463,7 +8463,7 @@
           <a:lstStyle/>
           <a:p>
             <a:pPr algn="ctr">
-              <a:defRPr sz="900" b="0">
+              <a:defRPr sz="1000" b="0">
                 <a:solidFill>
                   <a:srgbClr val="1B2A4A"/>
                 </a:solidFill>
@@ -8497,7 +8497,7 @@
           <a:lstStyle/>
           <a:p>
             <a:pPr algn="l">
-              <a:defRPr sz="900" b="0">
+              <a:defRPr sz="1000" b="0">
                 <a:solidFill>
                   <a:srgbClr val="333333"/>
                 </a:solidFill>
@@ -8510,7 +8510,7 @@
           </a:p>
           <a:p>
             <a:pPr algn="l">
-              <a:defRPr sz="900" b="0">
+              <a:defRPr sz="1000" b="0">
                 <a:solidFill>
                   <a:srgbClr val="333333"/>
                 </a:solidFill>
@@ -8687,7 +8687,7 @@
           <a:lstStyle/>
           <a:p>
             <a:pPr algn="ctr">
-              <a:defRPr sz="900" b="0">
+              <a:defRPr sz="1000" b="0">
                 <a:solidFill>
                   <a:srgbClr val="1B2A4A"/>
                 </a:solidFill>
@@ -8721,7 +8721,7 @@
           <a:lstStyle/>
           <a:p>
             <a:pPr algn="l">
-              <a:defRPr sz="900" b="0">
+              <a:defRPr sz="1000" b="0">
                 <a:solidFill>
                   <a:srgbClr val="333333"/>
                 </a:solidFill>
@@ -8734,7 +8734,7 @@
           </a:p>
           <a:p>
             <a:pPr algn="l">
-              <a:defRPr sz="900" b="0">
+              <a:defRPr sz="1000" b="0">
                 <a:solidFill>
                   <a:srgbClr val="333333"/>
                 </a:solidFill>
@@ -8911,7 +8911,7 @@
           <a:lstStyle/>
           <a:p>
             <a:pPr algn="ctr">
-              <a:defRPr sz="900" b="0">
+              <a:defRPr sz="1000" b="0">
                 <a:solidFill>
                   <a:srgbClr val="1B2A4A"/>
                 </a:solidFill>
@@ -8945,7 +8945,7 @@
           <a:lstStyle/>
           <a:p>
             <a:pPr algn="l">
-              <a:defRPr sz="900" b="0">
+              <a:defRPr sz="1000" b="0">
                 <a:solidFill>
                   <a:srgbClr val="333333"/>
                 </a:solidFill>
@@ -8958,7 +8958,7 @@
           </a:p>
           <a:p>
             <a:pPr algn="l">
-              <a:defRPr sz="900" b="0">
+              <a:defRPr sz="1000" b="0">
                 <a:solidFill>
                   <a:srgbClr val="333333"/>
                 </a:solidFill>
@@ -9135,7 +9135,7 @@
           <a:lstStyle/>
           <a:p>
             <a:pPr algn="ctr">
-              <a:defRPr sz="900" b="0">
+              <a:defRPr sz="1000" b="0">
                 <a:solidFill>
                   <a:srgbClr val="1B2A4A"/>
                 </a:solidFill>
@@ -9169,7 +9169,7 @@
           <a:lstStyle/>
           <a:p>
             <a:pPr algn="l">
-              <a:defRPr sz="900" b="0">
+              <a:defRPr sz="1000" b="0">
                 <a:solidFill>
                   <a:srgbClr val="333333"/>
                 </a:solidFill>
@@ -9182,7 +9182,7 @@
           </a:p>
           <a:p>
             <a:pPr algn="l">
-              <a:defRPr sz="900" b="0">
+              <a:defRPr sz="1000" b="0">
                 <a:solidFill>
                   <a:srgbClr val="333333"/>
                 </a:solidFill>
@@ -9359,7 +9359,7 @@
           <a:lstStyle/>
           <a:p>
             <a:pPr algn="ctr">
-              <a:defRPr sz="900" b="0">
+              <a:defRPr sz="1000" b="0">
                 <a:solidFill>
                   <a:srgbClr val="1B2A4A"/>
                 </a:solidFill>
@@ -9393,7 +9393,7 @@
           <a:lstStyle/>
           <a:p>
             <a:pPr algn="l">
-              <a:defRPr sz="900" b="0">
+              <a:defRPr sz="1000" b="0">
                 <a:solidFill>
                   <a:srgbClr val="333333"/>
                 </a:solidFill>
@@ -9406,7 +9406,7 @@
           </a:p>
           <a:p>
             <a:pPr algn="l">
-              <a:defRPr sz="900" b="0">
+              <a:defRPr sz="1000" b="0">
                 <a:solidFill>
                   <a:srgbClr val="333333"/>
                 </a:solidFill>
@@ -9583,7 +9583,7 @@
           <a:lstStyle/>
           <a:p>
             <a:pPr algn="ctr">
-              <a:defRPr sz="900" b="0">
+              <a:defRPr sz="1000" b="0">
                 <a:solidFill>
                   <a:srgbClr val="1B2A4A"/>
                 </a:solidFill>
@@ -9617,7 +9617,7 @@
           <a:lstStyle/>
           <a:p>
             <a:pPr algn="l">
-              <a:defRPr sz="900" b="0">
+              <a:defRPr sz="1000" b="0">
                 <a:solidFill>
                   <a:srgbClr val="333333"/>
                 </a:solidFill>
@@ -9630,7 +9630,7 @@
           </a:p>
           <a:p>
             <a:pPr algn="l">
-              <a:defRPr sz="900" b="0">
+              <a:defRPr sz="1000" b="0">
                 <a:solidFill>
                   <a:srgbClr val="333333"/>
                 </a:solidFill>
@@ -9807,7 +9807,7 @@
           <a:lstStyle/>
           <a:p>
             <a:pPr algn="ctr">
-              <a:defRPr sz="900" b="0">
+              <a:defRPr sz="1000" b="0">
                 <a:solidFill>
                   <a:srgbClr val="1B2A4A"/>
                 </a:solidFill>
@@ -9841,7 +9841,7 @@
           <a:lstStyle/>
           <a:p>
             <a:pPr algn="l">
-              <a:defRPr sz="900" b="0">
+              <a:defRPr sz="1000" b="0">
                 <a:solidFill>
                   <a:srgbClr val="333333"/>
                 </a:solidFill>
@@ -9854,7 +9854,7 @@
           </a:p>
           <a:p>
             <a:pPr algn="l">
-              <a:defRPr sz="900" b="0">
+              <a:defRPr sz="1000" b="0">
                 <a:solidFill>
                   <a:srgbClr val="333333"/>
                 </a:solidFill>
@@ -10031,7 +10031,7 @@
           <a:lstStyle/>
           <a:p>
             <a:pPr algn="ctr">
-              <a:defRPr sz="900" b="0">
+              <a:defRPr sz="1000" b="0">
                 <a:solidFill>
                   <a:srgbClr val="1B2A4A"/>
                 </a:solidFill>
@@ -10065,7 +10065,7 @@
           <a:lstStyle/>
           <a:p>
             <a:pPr algn="l">
-              <a:defRPr sz="900" b="0">
+              <a:defRPr sz="1000" b="0">
                 <a:solidFill>
                   <a:srgbClr val="333333"/>
                 </a:solidFill>
@@ -10078,7 +10078,7 @@
           </a:p>
           <a:p>
             <a:pPr algn="l">
-              <a:defRPr sz="900" b="0">
+              <a:defRPr sz="1000" b="0">
                 <a:solidFill>
                   <a:srgbClr val="333333"/>
                 </a:solidFill>
@@ -10188,7 +10188,7 @@
       </p:sp>
       <p:pic>
         <p:nvPicPr>
-          <p:cNvPr id="4" name="Picture 3" descr="knu_emblem_official.jpg"/>
+          <p:cNvPr id="4" name="Picture 3" descr="knu_symbol_t.png"/>
           <p:cNvPicPr>
             <a:picLocks noChangeAspect="1"/>
           </p:cNvPicPr>
@@ -10360,7 +10360,7 @@
             <a:avLst/>
           </a:prstGeom>
           <a:solidFill>
-            <a:srgbClr val="FFFFFF"/>
+            <a:srgbClr val="E8F5E9"/>
           </a:solidFill>
           <a:ln w="12700">
             <a:solidFill>
@@ -10499,7 +10499,7 @@
             <a:avLst/>
           </a:prstGeom>
           <a:solidFill>
-            <a:srgbClr val="FFFFFF"/>
+            <a:srgbClr val="E3F2FD"/>
           </a:solidFill>
           <a:ln w="12700">
             <a:solidFill>
@@ -10638,7 +10638,7 @@
             <a:avLst/>
           </a:prstGeom>
           <a:solidFill>
-            <a:srgbClr val="FFFFFF"/>
+            <a:srgbClr val="FFF3E0"/>
           </a:solidFill>
           <a:ln w="12700">
             <a:solidFill>
@@ -10859,7 +10859,7 @@
       </p:sp>
       <p:pic>
         <p:nvPicPr>
-          <p:cNvPr id="4" name="Picture 3" descr="knu_emblem_official.jpg"/>
+          <p:cNvPr id="4" name="Picture 3" descr="knu_symbol_t.png"/>
           <p:cNvPicPr>
             <a:picLocks noChangeAspect="1"/>
           </p:cNvPicPr>
@@ -11485,7 +11485,7 @@
           <a:lstStyle/>
           <a:p>
             <a:pPr algn="l">
-              <a:defRPr sz="900" b="0">
+              <a:defRPr sz="1000" b="0">
                 <a:solidFill>
                   <a:srgbClr val="333333"/>
                 </a:solidFill>
@@ -11498,7 +11498,7 @@
           </a:p>
           <a:p>
             <a:pPr algn="l">
-              <a:defRPr sz="900" b="0">
+              <a:defRPr sz="1000" b="0">
                 <a:solidFill>
                   <a:srgbClr val="333333"/>
                 </a:solidFill>
@@ -11577,7 +11577,7 @@
           <a:lstStyle/>
           <a:p>
             <a:pPr algn="l">
-              <a:defRPr sz="900" b="0">
+              <a:defRPr sz="1000" b="0">
                 <a:solidFill>
                   <a:srgbClr val="333333"/>
                 </a:solidFill>
@@ -11590,7 +11590,7 @@
           </a:p>
           <a:p>
             <a:pPr algn="l">
-              <a:defRPr sz="900" b="0">
+              <a:defRPr sz="1000" b="0">
                 <a:solidFill>
                   <a:srgbClr val="333333"/>
                 </a:solidFill>
@@ -11669,7 +11669,7 @@
           <a:lstStyle/>
           <a:p>
             <a:pPr algn="l">
-              <a:defRPr sz="900" b="0">
+              <a:defRPr sz="1000" b="0">
                 <a:solidFill>
                   <a:srgbClr val="333333"/>
                 </a:solidFill>
@@ -11682,7 +11682,7 @@
           </a:p>
           <a:p>
             <a:pPr algn="l">
-              <a:defRPr sz="900" b="0">
+              <a:defRPr sz="1000" b="0">
                 <a:solidFill>
                   <a:srgbClr val="333333"/>
                 </a:solidFill>
@@ -11816,7 +11816,7 @@
       </p:sp>
       <p:pic>
         <p:nvPicPr>
-          <p:cNvPr id="4" name="Picture 3" descr="knu_emblem_official.jpg"/>
+          <p:cNvPr id="4" name="Picture 3" descr="knu_symbol_t.png"/>
           <p:cNvPicPr>
             <a:picLocks noChangeAspect="1"/>
           </p:cNvPicPr>
@@ -12661,7 +12661,7 @@
       </p:sp>
       <p:pic>
         <p:nvPicPr>
-          <p:cNvPr id="4" name="Picture 3" descr="knu_emblem_official.jpg"/>
+          <p:cNvPr id="4" name="Picture 3" descr="knu_symbol_t.png"/>
           <p:cNvPicPr>
             <a:picLocks noChangeAspect="1"/>
           </p:cNvPicPr>
@@ -13489,7 +13489,7 @@
       </p:sp>
       <p:pic>
         <p:nvPicPr>
-          <p:cNvPr id="4" name="Picture 3" descr="knu_emblem_official.jpg"/>
+          <p:cNvPr id="4" name="Picture 3" descr="knu_symbol_t.png"/>
           <p:cNvPicPr>
             <a:picLocks noChangeAspect="1"/>
           </p:cNvPicPr>
@@ -14619,7 +14619,7 @@
       </p:sp>
       <p:pic>
         <p:nvPicPr>
-          <p:cNvPr id="4" name="Picture 3" descr="knu_emblem_official.jpg"/>
+          <p:cNvPr id="4" name="Picture 3" descr="knu_symbol_t.png"/>
           <p:cNvPicPr>
             <a:picLocks noChangeAspect="1"/>
           </p:cNvPicPr>
@@ -14927,7 +14927,7 @@
           <a:lstStyle/>
           <a:p>
             <a:pPr algn="l">
-              <a:defRPr sz="1100" b="1">
+              <a:defRPr sz="1200" b="1">
                 <a:solidFill>
                   <a:srgbClr val="1B2A4A"/>
                 </a:solidFill>
@@ -14982,7 +14982,7 @@
           <a:lstStyle/>
           <a:p>
             <a:pPr algn="ctr">
-              <a:defRPr sz="1100" b="0">
+              <a:defRPr sz="1200" b="0">
                 <a:solidFill>
                   <a:srgbClr val="333333"/>
                 </a:solidFill>
@@ -15071,7 +15071,7 @@
           <a:lstStyle/>
           <a:p>
             <a:pPr algn="ctr">
-              <a:defRPr sz="1100" b="1">
+              <a:defRPr sz="1200" b="1">
                 <a:solidFill>
                   <a:srgbClr val="333333"/>
                 </a:solidFill>
@@ -15105,7 +15105,7 @@
           <a:lstStyle/>
           <a:p>
             <a:pPr algn="l">
-              <a:defRPr sz="1100" b="1">
+              <a:defRPr sz="1200" b="1">
                 <a:solidFill>
                   <a:srgbClr val="1B2A4A"/>
                 </a:solidFill>
@@ -15160,7 +15160,7 @@
           <a:lstStyle/>
           <a:p>
             <a:pPr algn="ctr">
-              <a:defRPr sz="1100" b="0">
+              <a:defRPr sz="1200" b="0">
                 <a:solidFill>
                   <a:srgbClr val="333333"/>
                 </a:solidFill>
@@ -15249,7 +15249,7 @@
           <a:lstStyle/>
           <a:p>
             <a:pPr algn="ctr">
-              <a:defRPr sz="1100" b="1">
+              <a:defRPr sz="1200" b="1">
                 <a:solidFill>
                   <a:srgbClr val="333333"/>
                 </a:solidFill>
@@ -15283,7 +15283,7 @@
           <a:lstStyle/>
           <a:p>
             <a:pPr algn="l">
-              <a:defRPr sz="1100" b="1">
+              <a:defRPr sz="1200" b="1">
                 <a:solidFill>
                   <a:srgbClr val="1B2A4A"/>
                 </a:solidFill>
@@ -15338,7 +15338,7 @@
           <a:lstStyle/>
           <a:p>
             <a:pPr algn="ctr">
-              <a:defRPr sz="1100" b="0">
+              <a:defRPr sz="1200" b="0">
                 <a:solidFill>
                   <a:srgbClr val="333333"/>
                 </a:solidFill>
@@ -15427,7 +15427,7 @@
           <a:lstStyle/>
           <a:p>
             <a:pPr algn="ctr">
-              <a:defRPr sz="1100" b="1">
+              <a:defRPr sz="1200" b="1">
                 <a:solidFill>
                   <a:srgbClr val="333333"/>
                 </a:solidFill>
@@ -15461,7 +15461,7 @@
           <a:lstStyle/>
           <a:p>
             <a:pPr algn="l">
-              <a:defRPr sz="1100" b="1">
+              <a:defRPr sz="1200" b="1">
                 <a:solidFill>
                   <a:srgbClr val="1B2A4A"/>
                 </a:solidFill>
@@ -15516,7 +15516,7 @@
           <a:lstStyle/>
           <a:p>
             <a:pPr algn="ctr">
-              <a:defRPr sz="1100" b="0">
+              <a:defRPr sz="1200" b="0">
                 <a:solidFill>
                   <a:srgbClr val="333333"/>
                 </a:solidFill>
@@ -15605,7 +15605,7 @@
           <a:lstStyle/>
           <a:p>
             <a:pPr algn="ctr">
-              <a:defRPr sz="1100" b="1">
+              <a:defRPr sz="1200" b="1">
                 <a:solidFill>
                   <a:srgbClr val="333333"/>
                 </a:solidFill>
@@ -15639,7 +15639,7 @@
           <a:lstStyle/>
           <a:p>
             <a:pPr algn="l">
-              <a:defRPr sz="1100" b="1">
+              <a:defRPr sz="1200" b="1">
                 <a:solidFill>
                   <a:srgbClr val="1B2A4A"/>
                 </a:solidFill>
@@ -15694,7 +15694,7 @@
           <a:lstStyle/>
           <a:p>
             <a:pPr algn="ctr">
-              <a:defRPr sz="1100" b="0">
+              <a:defRPr sz="1200" b="0">
                 <a:solidFill>
                   <a:srgbClr val="333333"/>
                 </a:solidFill>
@@ -15783,7 +15783,7 @@
           <a:lstStyle/>
           <a:p>
             <a:pPr algn="ctr">
-              <a:defRPr sz="1100" b="1">
+              <a:defRPr sz="1200" b="1">
                 <a:solidFill>
                   <a:srgbClr val="333333"/>
                 </a:solidFill>
@@ -15804,7 +15804,7 @@
         </p:nvSpPr>
         <p:spPr>
           <a:xfrm>
-            <a:off x="1371600" y="6035040"/>
+            <a:off x="1371600" y="5760720"/>
             <a:ext cx="9418320" cy="548640"/>
           </a:xfrm>
           <a:prstGeom prst="roundRect">
@@ -15948,7 +15948,7 @@
       </p:sp>
       <p:pic>
         <p:nvPicPr>
-          <p:cNvPr id="4" name="Picture 3" descr="knu_emblem_official.jpg"/>
+          <p:cNvPr id="4" name="Picture 3" descr="knu_symbol_t.png"/>
           <p:cNvPicPr>
             <a:picLocks noChangeAspect="1"/>
           </p:cNvPicPr>
@@ -16447,7 +16447,7 @@
       </p:sp>
       <p:pic>
         <p:nvPicPr>
-          <p:cNvPr id="4" name="Picture 3" descr="knu_emblem_official.jpg"/>
+          <p:cNvPr id="4" name="Picture 3" descr="knu_symbol_t.png"/>
           <p:cNvPicPr>
             <a:picLocks noChangeAspect="1"/>
           </p:cNvPicPr>
@@ -16688,7 +16688,7 @@
           <a:lstStyle/>
           <a:p>
             <a:pPr algn="l">
-              <a:defRPr sz="1100" b="0">
+              <a:defRPr sz="1300" b="0">
                 <a:solidFill>
                   <a:srgbClr val="333333"/>
                 </a:solidFill>
@@ -16809,7 +16809,7 @@
           <a:lstStyle/>
           <a:p>
             <a:pPr algn="l">
-              <a:defRPr sz="1100" b="0">
+              <a:defRPr sz="1300" b="0">
                 <a:solidFill>
                   <a:srgbClr val="333333"/>
                 </a:solidFill>
@@ -16930,7 +16930,7 @@
           <a:lstStyle/>
           <a:p>
             <a:pPr algn="l">
-              <a:defRPr sz="1100" b="0">
+              <a:defRPr sz="1300" b="0">
                 <a:solidFill>
                   <a:srgbClr val="333333"/>
                 </a:solidFill>
@@ -17051,7 +17051,7 @@
           <a:lstStyle/>
           <a:p>
             <a:pPr algn="l">
-              <a:defRPr sz="1100" b="0">
+              <a:defRPr sz="1300" b="0">
                 <a:solidFill>
                   <a:srgbClr val="333333"/>
                 </a:solidFill>
@@ -17172,7 +17172,7 @@
           <a:lstStyle/>
           <a:p>
             <a:pPr algn="l">
-              <a:defRPr sz="1100" b="0">
+              <a:defRPr sz="1300" b="0">
                 <a:solidFill>
                   <a:srgbClr val="333333"/>
                 </a:solidFill>
@@ -17293,7 +17293,7 @@
           <a:lstStyle/>
           <a:p>
             <a:pPr algn="l">
-              <a:defRPr sz="1100" b="0">
+              <a:defRPr sz="1300" b="0">
                 <a:solidFill>
                   <a:srgbClr val="333333"/>
                 </a:solidFill>
@@ -17403,7 +17403,7 @@
       </p:sp>
       <p:pic>
         <p:nvPicPr>
-          <p:cNvPr id="4" name="Picture 3" descr="knu_emblem_official.jpg"/>
+          <p:cNvPr id="4" name="Picture 3" descr="knu_symbol_t.png"/>
           <p:cNvPicPr>
             <a:picLocks noChangeAspect="1"/>
           </p:cNvPicPr>
@@ -17544,7 +17544,7 @@
         </p:nvSpPr>
         <p:spPr>
           <a:xfrm>
-            <a:off x="548640" y="1371600"/>
+            <a:off x="425196" y="1371600"/>
             <a:ext cx="3566160" cy="4389120"/>
           </a:xfrm>
           <a:prstGeom prst="roundRect">
@@ -17589,7 +17589,7 @@
         </p:nvSpPr>
         <p:spPr>
           <a:xfrm>
-            <a:off x="548640" y="1645920"/>
+            <a:off x="425196" y="1645920"/>
             <a:ext cx="3566160" cy="1097280"/>
           </a:xfrm>
           <a:prstGeom prst="rect">
@@ -17623,7 +17623,7 @@
         </p:nvSpPr>
         <p:spPr>
           <a:xfrm>
-            <a:off x="548640" y="2743200"/>
+            <a:off x="425196" y="2743200"/>
             <a:ext cx="3566160" cy="457200"/>
           </a:xfrm>
           <a:prstGeom prst="rect">
@@ -17657,7 +17657,7 @@
         </p:nvSpPr>
         <p:spPr>
           <a:xfrm>
-            <a:off x="822960" y="3383280"/>
+            <a:off x="699516" y="3383280"/>
             <a:ext cx="3017520" cy="2194560"/>
           </a:xfrm>
           <a:prstGeom prst="rect">
@@ -17717,7 +17717,7 @@
         </p:nvSpPr>
         <p:spPr>
           <a:xfrm>
-            <a:off x="4389120" y="1371600"/>
+            <a:off x="4311396" y="1371600"/>
             <a:ext cx="3566160" cy="4389120"/>
           </a:xfrm>
           <a:prstGeom prst="roundRect">
@@ -17762,7 +17762,7 @@
         </p:nvSpPr>
         <p:spPr>
           <a:xfrm>
-            <a:off x="4389120" y="1645920"/>
+            <a:off x="4311396" y="1645920"/>
             <a:ext cx="3566160" cy="1097280"/>
           </a:xfrm>
           <a:prstGeom prst="rect">
@@ -17796,7 +17796,7 @@
         </p:nvSpPr>
         <p:spPr>
           <a:xfrm>
-            <a:off x="4389120" y="2743200"/>
+            <a:off x="4311396" y="2743200"/>
             <a:ext cx="3566160" cy="457200"/>
           </a:xfrm>
           <a:prstGeom prst="rect">
@@ -17830,7 +17830,7 @@
         </p:nvSpPr>
         <p:spPr>
           <a:xfrm>
-            <a:off x="4663440" y="3383280"/>
+            <a:off x="4585716" y="3383280"/>
             <a:ext cx="3017520" cy="2194560"/>
           </a:xfrm>
           <a:prstGeom prst="rect">
@@ -17890,7 +17890,7 @@
         </p:nvSpPr>
         <p:spPr>
           <a:xfrm>
-            <a:off x="8229600" y="1371600"/>
+            <a:off x="8197596" y="1371600"/>
             <a:ext cx="3566160" cy="4389120"/>
           </a:xfrm>
           <a:prstGeom prst="roundRect">
@@ -17935,7 +17935,7 @@
         </p:nvSpPr>
         <p:spPr>
           <a:xfrm>
-            <a:off x="8229600" y="1645920"/>
+            <a:off x="8197596" y="1645920"/>
             <a:ext cx="3566160" cy="1097280"/>
           </a:xfrm>
           <a:prstGeom prst="rect">
@@ -17969,7 +17969,7 @@
         </p:nvSpPr>
         <p:spPr>
           <a:xfrm>
-            <a:off x="8229600" y="2743200"/>
+            <a:off x="8197596" y="2743200"/>
             <a:ext cx="3566160" cy="457200"/>
           </a:xfrm>
           <a:prstGeom prst="rect">
@@ -18003,7 +18003,7 @@
         </p:nvSpPr>
         <p:spPr>
           <a:xfrm>
-            <a:off x="8503920" y="3383280"/>
+            <a:off x="8471916" y="3383280"/>
             <a:ext cx="3017520" cy="2194560"/>
           </a:xfrm>
           <a:prstGeom prst="rect">
@@ -18165,7 +18165,7 @@
       </p:sp>
       <p:pic>
         <p:nvPicPr>
-          <p:cNvPr id="4" name="Picture 3" descr="knu_emblem_official.jpg"/>
+          <p:cNvPr id="4" name="Picture 3" descr="knu_symbol_t.png"/>
           <p:cNvPicPr>
             <a:picLocks noChangeAspect="1"/>
           </p:cNvPicPr>
@@ -18499,7 +18499,7 @@
           <a:lstStyle/>
           <a:p>
             <a:pPr algn="l">
-              <a:defRPr sz="1100" b="0">
+              <a:defRPr sz="1200" b="0">
                 <a:solidFill>
                   <a:srgbClr val="333333"/>
                 </a:solidFill>
@@ -18512,7 +18512,7 @@
           </a:p>
           <a:p>
             <a:pPr algn="l">
-              <a:defRPr sz="1100" b="0">
+              <a:defRPr sz="1200" b="0">
                 <a:solidFill>
                   <a:srgbClr val="333333"/>
                 </a:solidFill>
@@ -18525,7 +18525,7 @@
           </a:p>
           <a:p>
             <a:pPr algn="l">
-              <a:defRPr sz="1100" b="0">
+              <a:defRPr sz="1200" b="0">
                 <a:solidFill>
                   <a:srgbClr val="333333"/>
                 </a:solidFill>
@@ -18715,7 +18715,7 @@
           <a:lstStyle/>
           <a:p>
             <a:pPr algn="l">
-              <a:defRPr sz="1100" b="0">
+              <a:defRPr sz="1200" b="0">
                 <a:solidFill>
                   <a:srgbClr val="333333"/>
                 </a:solidFill>
@@ -18723,12 +18723,12 @@
               </a:defRPr>
             </a:pPr>
             <a:r>
-              <a:t>Scoring x Pathogen</a:t>
-            </a:r>
-          </a:p>
-          <a:p>
-            <a:pPr algn="l">
-              <a:defRPr sz="1100" b="0">
+              <a:t>Detection Family × Pathogen</a:t>
+            </a:r>
+          </a:p>
+          <a:p>
+            <a:pPr algn="l">
+              <a:defRPr sz="1200" b="0">
                 <a:solidFill>
                   <a:srgbClr val="333333"/>
                 </a:solidFill>
@@ -18741,7 +18741,7 @@
           </a:p>
           <a:p>
             <a:pPr algn="l">
-              <a:defRPr sz="1100" b="0">
+              <a:defRPr sz="1200" b="0">
                 <a:solidFill>
                   <a:srgbClr val="333333"/>
                 </a:solidFill>
@@ -18931,7 +18931,7 @@
           <a:lstStyle/>
           <a:p>
             <a:pPr algn="l">
-              <a:defRPr sz="1100" b="0">
+              <a:defRPr sz="1200" b="0">
                 <a:solidFill>
                   <a:srgbClr val="333333"/>
                 </a:solidFill>
@@ -18944,7 +18944,7 @@
           </a:p>
           <a:p>
             <a:pPr algn="l">
-              <a:defRPr sz="1100" b="0">
+              <a:defRPr sz="1200" b="0">
                 <a:solidFill>
                   <a:srgbClr val="333333"/>
                 </a:solidFill>
@@ -18957,7 +18957,7 @@
           </a:p>
           <a:p>
             <a:pPr algn="l">
-              <a:defRPr sz="1100" b="0">
+              <a:defRPr sz="1200" b="0">
                 <a:solidFill>
                   <a:srgbClr val="333333"/>
                 </a:solidFill>
@@ -19067,7 +19067,7 @@
       </p:sp>
       <p:pic>
         <p:nvPicPr>
-          <p:cNvPr id="4" name="Picture 3" descr="knu_emblem_official.jpg"/>
+          <p:cNvPr id="4" name="Picture 3" descr="knu_symbol_t.png"/>
           <p:cNvPicPr>
             <a:picLocks noChangeAspect="1"/>
           </p:cNvPicPr>
@@ -19371,7 +19371,7 @@
           <a:lstStyle/>
           <a:p>
             <a:pPr algn="l">
-              <a:defRPr sz="1100" b="0">
+              <a:defRPr sz="1200" b="0">
                 <a:solidFill>
                   <a:srgbClr val="333333"/>
                 </a:solidFill>
@@ -19384,7 +19384,7 @@
           </a:p>
           <a:p>
             <a:pPr algn="l">
-              <a:defRPr sz="1100" b="0">
+              <a:defRPr sz="1200" b="0">
                 <a:solidFill>
                   <a:srgbClr val="333333"/>
                 </a:solidFill>
@@ -19397,7 +19397,7 @@
           </a:p>
           <a:p>
             <a:pPr algn="l">
-              <a:defRPr sz="1100" b="0">
+              <a:defRPr sz="1200" b="0">
                 <a:solidFill>
                   <a:srgbClr val="333333"/>
                 </a:solidFill>
@@ -19410,7 +19410,7 @@
           </a:p>
           <a:p>
             <a:pPr algn="l">
-              <a:defRPr sz="1100" b="0">
+              <a:defRPr sz="1200" b="0">
                 <a:solidFill>
                   <a:srgbClr val="333333"/>
                 </a:solidFill>
@@ -19420,7 +19420,7 @@
           </a:p>
           <a:p>
             <a:pPr algn="l">
-              <a:defRPr sz="1100" b="0">
+              <a:defRPr sz="1200" b="0">
                 <a:solidFill>
                   <a:srgbClr val="333333"/>
                 </a:solidFill>
@@ -19433,7 +19433,7 @@
           </a:p>
           <a:p>
             <a:pPr algn="l">
-              <a:defRPr sz="1100" b="0">
+              <a:defRPr sz="1200" b="0">
                 <a:solidFill>
                   <a:srgbClr val="333333"/>
                 </a:solidFill>
@@ -19446,7 +19446,7 @@
           </a:p>
           <a:p>
             <a:pPr algn="l">
-              <a:defRPr sz="1100" b="0">
+              <a:defRPr sz="1200" b="0">
                 <a:solidFill>
                   <a:srgbClr val="333333"/>
                 </a:solidFill>
@@ -19456,7 +19456,7 @@
           </a:p>
           <a:p>
             <a:pPr algn="l">
-              <a:defRPr sz="1100" b="0">
+              <a:defRPr sz="1200" b="0">
                 <a:solidFill>
                   <a:srgbClr val="333333"/>
                 </a:solidFill>
@@ -19469,7 +19469,7 @@
           </a:p>
           <a:p>
             <a:pPr algn="l">
-              <a:defRPr sz="1100" b="0">
+              <a:defRPr sz="1200" b="0">
                 <a:solidFill>
                   <a:srgbClr val="333333"/>
                 </a:solidFill>
@@ -19579,7 +19579,7 @@
       </p:sp>
       <p:pic>
         <p:nvPicPr>
-          <p:cNvPr id="4" name="Picture 3" descr="knu_emblem_official.jpg"/>
+          <p:cNvPr id="4" name="Picture 3" descr="knu_symbol_t.png"/>
           <p:cNvPicPr>
             <a:picLocks noChangeAspect="1"/>
           </p:cNvPicPr>
@@ -20420,7 +20420,7 @@
       </p:sp>
       <p:pic>
         <p:nvPicPr>
-          <p:cNvPr id="4" name="Picture 3" descr="knu_emblem_official.jpg"/>
+          <p:cNvPr id="4" name="Picture 3" descr="knu_symbol_t.png"/>
           <p:cNvPicPr>
             <a:picLocks noChangeAspect="1"/>
           </p:cNvPicPr>
@@ -21860,7 +21860,7 @@
       </p:sp>
       <p:pic>
         <p:nvPicPr>
-          <p:cNvPr id="4" name="Picture 3" descr="knu_emblem_official.jpg"/>
+          <p:cNvPr id="4" name="Picture 3" descr="knu_symbol_t.png"/>
           <p:cNvPicPr>
             <a:picLocks noChangeAspect="1"/>
           </p:cNvPicPr>
@@ -22225,7 +22225,7 @@
           <a:lstStyle/>
           <a:p>
             <a:pPr algn="l">
-              <a:defRPr sz="1100" b="0">
+              <a:defRPr sz="1200" b="0">
                 <a:solidFill>
                   <a:srgbClr val="333333"/>
                 </a:solidFill>
@@ -22233,12 +22233,12 @@
               </a:defRPr>
             </a:pPr>
             <a:r>
-              <a:t>Scoring x Pathogen interaction</a:t>
-            </a:r>
-          </a:p>
-          <a:p>
-            <a:pPr algn="l">
-              <a:defRPr sz="1100" b="0">
+              <a:t>Detection Family × Pathogen</a:t>
+            </a:r>
+          </a:p>
+          <a:p>
+            <a:pPr algn="l">
+              <a:defRPr sz="1200" b="0">
                 <a:solidFill>
                   <a:srgbClr val="333333"/>
                 </a:solidFill>
@@ -22246,7 +22246,7 @@
               </a:defRPr>
             </a:pPr>
             <a:r>
-              <a:t>explains 28.5% of variance</a:t>
+              <a:t>interaction explains 28.5% of variance</a:t>
             </a:r>
           </a:p>
         </p:txBody>
@@ -22428,7 +22428,7 @@
           <a:lstStyle/>
           <a:p>
             <a:pPr algn="l">
-              <a:defRPr sz="1100" b="0">
+              <a:defRPr sz="1200" b="0">
                 <a:solidFill>
                   <a:srgbClr val="333333"/>
                 </a:solidFill>
@@ -22441,7 +22441,7 @@
           </a:p>
           <a:p>
             <a:pPr algn="l">
-              <a:defRPr sz="1100" b="0">
+              <a:defRPr sz="1200" b="0">
                 <a:solidFill>
                   <a:srgbClr val="333333"/>
                 </a:solidFill>
@@ -22631,7 +22631,7 @@
           <a:lstStyle/>
           <a:p>
             <a:pPr algn="l">
-              <a:defRPr sz="1100" b="0">
+              <a:defRPr sz="1200" b="0">
                 <a:solidFill>
                   <a:srgbClr val="333333"/>
                 </a:solidFill>
@@ -22644,7 +22644,7 @@
           </a:p>
           <a:p>
             <a:pPr algn="l">
-              <a:defRPr sz="1100" b="0">
+              <a:defRPr sz="1200" b="0">
                 <a:solidFill>
                   <a:srgbClr val="333333"/>
                 </a:solidFill>
@@ -22834,7 +22834,7 @@
           <a:lstStyle/>
           <a:p>
             <a:pPr algn="l">
-              <a:defRPr sz="1100" b="0">
+              <a:defRPr sz="1200" b="0">
                 <a:solidFill>
                   <a:srgbClr val="333333"/>
                 </a:solidFill>
@@ -22847,7 +22847,7 @@
           </a:p>
           <a:p>
             <a:pPr algn="l">
-              <a:defRPr sz="1100" b="0">
+              <a:defRPr sz="1200" b="0">
                 <a:solidFill>
                   <a:srgbClr val="333333"/>
                 </a:solidFill>
@@ -22957,7 +22957,7 @@
       </p:sp>
       <p:pic>
         <p:nvPicPr>
-          <p:cNvPr id="4" name="Picture 3" descr="knu_emblem_official.jpg"/>
+          <p:cNvPr id="4" name="Picture 3" descr="knu_symbol_t.png"/>
           <p:cNvPicPr>
             <a:picLocks noChangeAspect="1"/>
           </p:cNvPicPr>
@@ -23805,7 +23805,7 @@
         <p:spPr>
           <a:xfrm>
             <a:off x="8321040" y="3840480"/>
-            <a:ext cx="4011930" cy="228600"/>
+            <a:ext cx="3120390" cy="228600"/>
           </a:xfrm>
           <a:prstGeom prst="rect">
             <a:avLst/>
@@ -23847,8 +23847,8 @@
         </p:nvSpPr>
         <p:spPr>
           <a:xfrm>
-            <a:off x="12424410" y="3840480"/>
-            <a:ext cx="731520" cy="228600"/>
+            <a:off x="10801350" y="3840480"/>
+            <a:ext cx="594360" cy="228600"/>
           </a:xfrm>
           <a:prstGeom prst="rect">
             <a:avLst/>
@@ -23859,10 +23859,10 @@
           <a:bodyPr wrap="square" anchor="ctr"/>
           <a:lstStyle/>
           <a:p>
-            <a:pPr algn="l">
-              <a:defRPr sz="900" b="1">
-                <a:solidFill>
-                  <a:srgbClr val="2E7D32"/>
+            <a:pPr algn="r">
+              <a:defRPr sz="1100" b="1">
+                <a:solidFill>
+                  <a:srgbClr val="FFFFFF"/>
                 </a:solidFill>
                 <a:latin typeface="Calibri"/>
               </a:defRPr>
@@ -23916,7 +23916,7 @@
         <p:spPr>
           <a:xfrm>
             <a:off x="8321040" y="4270248"/>
-            <a:ext cx="2551176" cy="228600"/>
+            <a:ext cx="1984248" cy="228600"/>
           </a:xfrm>
           <a:prstGeom prst="rect">
             <a:avLst/>
@@ -23958,8 +23958,8 @@
         </p:nvSpPr>
         <p:spPr>
           <a:xfrm>
-            <a:off x="10963656" y="4270248"/>
-            <a:ext cx="731520" cy="228600"/>
+            <a:off x="9665208" y="4270248"/>
+            <a:ext cx="594360" cy="228600"/>
           </a:xfrm>
           <a:prstGeom prst="rect">
             <a:avLst/>
@@ -23970,10 +23970,10 @@
           <a:bodyPr wrap="square" anchor="ctr"/>
           <a:lstStyle/>
           <a:p>
-            <a:pPr algn="l">
-              <a:defRPr sz="900" b="1">
-                <a:solidFill>
-                  <a:srgbClr val="1565C0"/>
+            <a:pPr algn="r">
+              <a:defRPr sz="1100" b="1">
+                <a:solidFill>
+                  <a:srgbClr val="FFFFFF"/>
                 </a:solidFill>
                 <a:latin typeface="Calibri"/>
               </a:defRPr>
@@ -24027,7 +24027,7 @@
         <p:spPr>
           <a:xfrm>
             <a:off x="8321040" y="4700016"/>
-            <a:ext cx="1985391" cy="228600"/>
+            <a:ext cx="1544193" cy="228600"/>
           </a:xfrm>
           <a:prstGeom prst="rect">
             <a:avLst/>
@@ -24069,8 +24069,8 @@
         </p:nvSpPr>
         <p:spPr>
           <a:xfrm>
-            <a:off x="10397871" y="4700016"/>
-            <a:ext cx="731520" cy="228600"/>
+            <a:off x="9225153" y="4700016"/>
+            <a:ext cx="594360" cy="228600"/>
           </a:xfrm>
           <a:prstGeom prst="rect">
             <a:avLst/>
@@ -24081,10 +24081,10 @@
           <a:bodyPr wrap="square" anchor="ctr"/>
           <a:lstStyle/>
           <a:p>
-            <a:pPr algn="l">
-              <a:defRPr sz="900" b="1">
-                <a:solidFill>
-                  <a:srgbClr val="E65100"/>
+            <a:pPr algn="r">
+              <a:defRPr sz="1100" b="1">
+                <a:solidFill>
+                  <a:srgbClr val="FFFFFF"/>
                 </a:solidFill>
                 <a:latin typeface="Calibri"/>
               </a:defRPr>
@@ -24138,7 +24138,7 @@
         <p:spPr>
           <a:xfrm>
             <a:off x="8321040" y="5129784"/>
-            <a:ext cx="1419606" cy="228600"/>
+            <a:ext cx="1104138" cy="228600"/>
           </a:xfrm>
           <a:prstGeom prst="rect">
             <a:avLst/>
@@ -24180,8 +24180,8 @@
         </p:nvSpPr>
         <p:spPr>
           <a:xfrm>
-            <a:off x="9832086" y="5129784"/>
-            <a:ext cx="731520" cy="228600"/>
+            <a:off x="8785098" y="5129784"/>
+            <a:ext cx="594360" cy="228600"/>
           </a:xfrm>
           <a:prstGeom prst="rect">
             <a:avLst/>
@@ -24192,10 +24192,10 @@
           <a:bodyPr wrap="square" anchor="ctr"/>
           <a:lstStyle/>
           <a:p>
-            <a:pPr algn="l">
-              <a:defRPr sz="900" b="1">
-                <a:solidFill>
-                  <a:srgbClr val="C62828"/>
+            <a:pPr algn="r">
+              <a:defRPr sz="1100" b="1">
+                <a:solidFill>
+                  <a:srgbClr val="FFFFFF"/>
                 </a:solidFill>
                 <a:latin typeface="Calibri"/>
               </a:defRPr>
@@ -24249,7 +24249,7 @@
         <p:spPr>
           <a:xfrm>
             <a:off x="8321040" y="5559552"/>
-            <a:ext cx="10287" cy="228600"/>
+            <a:ext cx="8001" cy="228600"/>
           </a:xfrm>
           <a:prstGeom prst="rect">
             <a:avLst/>
@@ -24291,8 +24291,8 @@
         </p:nvSpPr>
         <p:spPr>
           <a:xfrm>
-            <a:off x="8422767" y="5559552"/>
-            <a:ext cx="731520" cy="228600"/>
+            <a:off x="8374761" y="5559552"/>
+            <a:ext cx="594360" cy="228600"/>
           </a:xfrm>
           <a:prstGeom prst="rect">
             <a:avLst/>
@@ -24304,7 +24304,7 @@
           <a:lstStyle/>
           <a:p>
             <a:pPr algn="l">
-              <a:defRPr sz="900" b="1">
+              <a:defRPr sz="1100" b="1">
                 <a:solidFill>
                   <a:srgbClr val="888888"/>
                 </a:solidFill>
@@ -24414,7 +24414,7 @@
       </p:sp>
       <p:pic>
         <p:nvPicPr>
-          <p:cNvPr id="4" name="Picture 3" descr="knu_emblem_official.jpg"/>
+          <p:cNvPr id="4" name="Picture 3" descr="knu_symbol_t.png"/>
           <p:cNvPicPr>
             <a:picLocks noChangeAspect="1"/>
           </p:cNvPicPr>
@@ -25237,7 +25237,7 @@
       </p:sp>
       <p:pic>
         <p:nvPicPr>
-          <p:cNvPr id="4" name="Picture 3" descr="knu_emblem_official.jpg"/>
+          <p:cNvPr id="4" name="Picture 3" descr="knu_symbol_t.png"/>
           <p:cNvPicPr>
             <a:picLocks noChangeAspect="1"/>
           </p:cNvPicPr>
@@ -25471,7 +25471,7 @@
         <p:spPr>
           <a:xfrm>
             <a:off x="7772400" y="1993392"/>
-            <a:ext cx="3566160" cy="320040"/>
+            <a:ext cx="3120390" cy="320040"/>
           </a:xfrm>
           <a:prstGeom prst="rect">
             <a:avLst/>
@@ -25513,8 +25513,8 @@
         </p:nvSpPr>
         <p:spPr>
           <a:xfrm>
-            <a:off x="11430000" y="1993392"/>
-            <a:ext cx="914400" cy="320040"/>
+            <a:off x="10252710" y="1993392"/>
+            <a:ext cx="594360" cy="320040"/>
           </a:xfrm>
           <a:prstGeom prst="rect">
             <a:avLst/>
@@ -25525,10 +25525,10 @@
           <a:bodyPr wrap="square" anchor="ctr"/>
           <a:lstStyle/>
           <a:p>
-            <a:pPr algn="l">
+            <a:pPr algn="r">
               <a:defRPr sz="1100" b="1">
                 <a:solidFill>
-                  <a:srgbClr val="2E7D32"/>
+                  <a:srgbClr val="FFFFFF"/>
                 </a:solidFill>
                 <a:latin typeface="Calibri"/>
               </a:defRPr>
@@ -25582,7 +25582,7 @@
         <p:spPr>
           <a:xfrm>
             <a:off x="7772400" y="2907792"/>
-            <a:ext cx="2267712" cy="320040"/>
+            <a:ext cx="1984248" cy="320040"/>
           </a:xfrm>
           <a:prstGeom prst="rect">
             <a:avLst/>
@@ -25624,8 +25624,8 @@
         </p:nvSpPr>
         <p:spPr>
           <a:xfrm>
-            <a:off x="10131552" y="2907792"/>
-            <a:ext cx="914400" cy="320040"/>
+            <a:off x="9116568" y="2907792"/>
+            <a:ext cx="594360" cy="320040"/>
           </a:xfrm>
           <a:prstGeom prst="rect">
             <a:avLst/>
@@ -25636,10 +25636,10 @@
           <a:bodyPr wrap="square" anchor="ctr"/>
           <a:lstStyle/>
           <a:p>
-            <a:pPr algn="l">
+            <a:pPr algn="r">
               <a:defRPr sz="1100" b="1">
                 <a:solidFill>
-                  <a:srgbClr val="1565C0"/>
+                  <a:srgbClr val="FFFFFF"/>
                 </a:solidFill>
                 <a:latin typeface="Calibri"/>
               </a:defRPr>
@@ -25693,7 +25693,7 @@
         <p:spPr>
           <a:xfrm>
             <a:off x="7772400" y="3822192"/>
-            <a:ext cx="1764792" cy="320040"/>
+            <a:ext cx="1544193" cy="320040"/>
           </a:xfrm>
           <a:prstGeom prst="rect">
             <a:avLst/>
@@ -25735,8 +25735,8 @@
         </p:nvSpPr>
         <p:spPr>
           <a:xfrm>
-            <a:off x="9628632" y="3822192"/>
-            <a:ext cx="914400" cy="320040"/>
+            <a:off x="8676513" y="3822192"/>
+            <a:ext cx="594360" cy="320040"/>
           </a:xfrm>
           <a:prstGeom prst="rect">
             <a:avLst/>
@@ -25747,10 +25747,10 @@
           <a:bodyPr wrap="square" anchor="ctr"/>
           <a:lstStyle/>
           <a:p>
-            <a:pPr algn="l">
+            <a:pPr algn="r">
               <a:defRPr sz="1100" b="1">
                 <a:solidFill>
-                  <a:srgbClr val="E65100"/>
+                  <a:srgbClr val="FFFFFF"/>
                 </a:solidFill>
                 <a:latin typeface="Calibri"/>
               </a:defRPr>
@@ -25804,7 +25804,7 @@
         <p:spPr>
           <a:xfrm>
             <a:off x="7772400" y="4736592"/>
-            <a:ext cx="1261872" cy="320040"/>
+            <a:ext cx="1104138" cy="320040"/>
           </a:xfrm>
           <a:prstGeom prst="rect">
             <a:avLst/>
@@ -25846,8 +25846,8 @@
         </p:nvSpPr>
         <p:spPr>
           <a:xfrm>
-            <a:off x="9125712" y="4736592"/>
-            <a:ext cx="914400" cy="320040"/>
+            <a:off x="8236458" y="4736592"/>
+            <a:ext cx="594360" cy="320040"/>
           </a:xfrm>
           <a:prstGeom prst="rect">
             <a:avLst/>
@@ -25858,10 +25858,10 @@
           <a:bodyPr wrap="square" anchor="ctr"/>
           <a:lstStyle/>
           <a:p>
-            <a:pPr algn="l">
+            <a:pPr algn="r">
               <a:defRPr sz="1100" b="1">
                 <a:solidFill>
-                  <a:srgbClr val="C62828"/>
+                  <a:srgbClr val="FFFFFF"/>
                 </a:solidFill>
                 <a:latin typeface="Calibri"/>
               </a:defRPr>
@@ -25915,7 +25915,7 @@
         <p:spPr>
           <a:xfrm>
             <a:off x="7772400" y="5650992"/>
-            <a:ext cx="9144" cy="320040"/>
+            <a:ext cx="8001" cy="320040"/>
           </a:xfrm>
           <a:prstGeom prst="rect">
             <a:avLst/>
@@ -25957,8 +25957,8 @@
         </p:nvSpPr>
         <p:spPr>
           <a:xfrm>
-            <a:off x="7872984" y="5650992"/>
-            <a:ext cx="914400" cy="320040"/>
+            <a:off x="7826121" y="5650992"/>
+            <a:ext cx="594360" cy="320040"/>
           </a:xfrm>
           <a:prstGeom prst="rect">
             <a:avLst/>
@@ -26080,7 +26080,7 @@
       </p:sp>
       <p:pic>
         <p:nvPicPr>
-          <p:cNvPr id="4" name="Picture 3" descr="knu_emblem_official.jpg"/>
+          <p:cNvPr id="4" name="Picture 3" descr="knu_symbol_t.png"/>
           <p:cNvPicPr>
             <a:picLocks noChangeAspect="1"/>
           </p:cNvPicPr>
@@ -26416,7 +26416,7 @@
           <a:lstStyle/>
           <a:p>
             <a:pPr algn="l">
-              <a:defRPr sz="900" b="0">
+              <a:defRPr sz="1000" b="0">
                 <a:solidFill>
                   <a:srgbClr val="888888"/>
                 </a:solidFill>
@@ -26632,7 +26632,7 @@
           <a:lstStyle/>
           <a:p>
             <a:pPr algn="l">
-              <a:defRPr sz="900" b="0">
+              <a:defRPr sz="1000" b="0">
                 <a:solidFill>
                   <a:srgbClr val="888888"/>
                 </a:solidFill>
@@ -26848,7 +26848,7 @@
           <a:lstStyle/>
           <a:p>
             <a:pPr algn="l">
-              <a:defRPr sz="900" b="0">
+              <a:defRPr sz="1000" b="0">
                 <a:solidFill>
                   <a:srgbClr val="888888"/>
                 </a:solidFill>
@@ -27064,7 +27064,7 @@
           <a:lstStyle/>
           <a:p>
             <a:pPr algn="l">
-              <a:defRPr sz="900" b="0">
+              <a:defRPr sz="1000" b="0">
                 <a:solidFill>
                   <a:srgbClr val="888888"/>
                 </a:solidFill>
@@ -27174,7 +27174,7 @@
       </p:sp>
       <p:pic>
         <p:nvPicPr>
-          <p:cNvPr id="4" name="Picture 3" descr="knu_emblem_official.jpg"/>
+          <p:cNvPr id="4" name="Picture 3" descr="knu_symbol_t.png"/>
           <p:cNvPicPr>
             <a:picLocks noChangeAspect="1"/>
           </p:cNvPicPr>
@@ -27484,7 +27484,7 @@
           <a:lstStyle/>
           <a:p>
             <a:pPr algn="l">
-              <a:defRPr sz="1100" b="0">
+              <a:defRPr sz="1300" b="0">
                 <a:solidFill>
                   <a:srgbClr val="333333"/>
                 </a:solidFill>
@@ -27497,7 +27497,7 @@
           </a:p>
           <a:p>
             <a:pPr algn="l">
-              <a:defRPr sz="1100" b="0">
+              <a:defRPr sz="1300" b="0">
                 <a:solidFill>
                   <a:srgbClr val="333333"/>
                 </a:solidFill>
@@ -27510,7 +27510,7 @@
           </a:p>
           <a:p>
             <a:pPr algn="l">
-              <a:defRPr sz="1100" b="0">
+              <a:defRPr sz="1300" b="0">
                 <a:solidFill>
                   <a:srgbClr val="333333"/>
                 </a:solidFill>
@@ -27520,7 +27520,7 @@
           </a:p>
           <a:p>
             <a:pPr algn="l">
-              <a:defRPr sz="1100" b="0">
+              <a:defRPr sz="1300" b="0">
                 <a:solidFill>
                   <a:srgbClr val="333333"/>
                 </a:solidFill>
@@ -27533,7 +27533,7 @@
           </a:p>
           <a:p>
             <a:pPr algn="l">
-              <a:defRPr sz="1100" b="0">
+              <a:defRPr sz="1300" b="0">
                 <a:solidFill>
                   <a:srgbClr val="333333"/>
                 </a:solidFill>
@@ -27747,7 +27747,7 @@
           <a:lstStyle/>
           <a:p>
             <a:pPr algn="l">
-              <a:defRPr sz="1100" b="0">
+              <a:defRPr sz="1300" b="0">
                 <a:solidFill>
                   <a:srgbClr val="333333"/>
                 </a:solidFill>
@@ -27760,7 +27760,7 @@
           </a:p>
           <a:p>
             <a:pPr algn="l">
-              <a:defRPr sz="1100" b="0">
+              <a:defRPr sz="1300" b="0">
                 <a:solidFill>
                   <a:srgbClr val="333333"/>
                 </a:solidFill>
@@ -27773,7 +27773,7 @@
           </a:p>
           <a:p>
             <a:pPr algn="l">
-              <a:defRPr sz="1100" b="0">
+              <a:defRPr sz="1300" b="0">
                 <a:solidFill>
                   <a:srgbClr val="333333"/>
                 </a:solidFill>
@@ -27783,7 +27783,7 @@
           </a:p>
           <a:p>
             <a:pPr algn="l">
-              <a:defRPr sz="1100" b="0">
+              <a:defRPr sz="1300" b="0">
                 <a:solidFill>
                   <a:srgbClr val="333333"/>
                 </a:solidFill>
@@ -27796,7 +27796,7 @@
           </a:p>
           <a:p>
             <a:pPr algn="l">
-              <a:defRPr sz="1100" b="0">
+              <a:defRPr sz="1300" b="0">
                 <a:solidFill>
                   <a:srgbClr val="333333"/>
                 </a:solidFill>
@@ -27930,7 +27930,7 @@
       </p:sp>
       <p:pic>
         <p:nvPicPr>
-          <p:cNvPr id="4" name="Picture 3" descr="knu_emblem_official.jpg"/>
+          <p:cNvPr id="4" name="Picture 3" descr="knu_symbol_t.png"/>
           <p:cNvPicPr>
             <a:picLocks noChangeAspect="1"/>
           </p:cNvPicPr>
@@ -28628,7 +28628,7 @@
       </p:sp>
       <p:pic>
         <p:nvPicPr>
-          <p:cNvPr id="4" name="Picture 3" descr="knu_emblem_official.jpg"/>
+          <p:cNvPr id="4" name="Picture 3" descr="knu_symbol_t.png"/>
           <p:cNvPicPr>
             <a:picLocks noChangeAspect="1"/>
           </p:cNvPicPr>
@@ -28947,7 +28947,7 @@
           <a:lstStyle/>
           <a:p>
             <a:pPr algn="l">
-              <a:defRPr sz="1100" b="0">
+              <a:defRPr sz="1200" b="0">
                 <a:solidFill>
                   <a:srgbClr val="333333"/>
                 </a:solidFill>
@@ -28960,7 +28960,7 @@
           </a:p>
           <a:p>
             <a:pPr algn="l">
-              <a:defRPr sz="1100" b="0">
+              <a:defRPr sz="1200" b="0">
                 <a:solidFill>
                   <a:srgbClr val="333333"/>
                 </a:solidFill>
@@ -29082,7 +29082,7 @@
           <a:lstStyle/>
           <a:p>
             <a:pPr algn="l">
-              <a:defRPr sz="1100" b="0">
+              <a:defRPr sz="1200" b="0">
                 <a:solidFill>
                   <a:srgbClr val="333333"/>
                 </a:solidFill>
@@ -29095,7 +29095,7 @@
           </a:p>
           <a:p>
             <a:pPr algn="l">
-              <a:defRPr sz="1100" b="0">
+              <a:defRPr sz="1200" b="0">
                 <a:solidFill>
                   <a:srgbClr val="333333"/>
                 </a:solidFill>
@@ -29217,7 +29217,7 @@
           <a:lstStyle/>
           <a:p>
             <a:pPr algn="l">
-              <a:defRPr sz="1100" b="0">
+              <a:defRPr sz="1200" b="0">
                 <a:solidFill>
                   <a:srgbClr val="333333"/>
                 </a:solidFill>
@@ -29230,7 +29230,7 @@
           </a:p>
           <a:p>
             <a:pPr algn="l">
-              <a:defRPr sz="1100" b="0">
+              <a:defRPr sz="1200" b="0">
                 <a:solidFill>
                   <a:srgbClr val="333333"/>
                 </a:solidFill>
@@ -29352,7 +29352,7 @@
           <a:lstStyle/>
           <a:p>
             <a:pPr algn="l">
-              <a:defRPr sz="1100" b="0">
+              <a:defRPr sz="1200" b="0">
                 <a:solidFill>
                   <a:srgbClr val="333333"/>
                 </a:solidFill>
@@ -29365,7 +29365,7 @@
           </a:p>
           <a:p>
             <a:pPr algn="l">
-              <a:defRPr sz="1100" b="0">
+              <a:defRPr sz="1200" b="0">
                 <a:solidFill>
                   <a:srgbClr val="333333"/>
                 </a:solidFill>
@@ -29564,7 +29564,7 @@
           <a:lstStyle/>
           <a:p>
             <a:pPr algn="l">
-              <a:defRPr sz="1100" b="0">
+              <a:defRPr sz="1200" b="0">
                 <a:solidFill>
                   <a:srgbClr val="333333"/>
                 </a:solidFill>
@@ -29577,7 +29577,7 @@
           </a:p>
           <a:p>
             <a:pPr algn="l">
-              <a:defRPr sz="1100" b="0">
+              <a:defRPr sz="1200" b="0">
                 <a:solidFill>
                   <a:srgbClr val="333333"/>
                 </a:solidFill>
@@ -29699,7 +29699,7 @@
           <a:lstStyle/>
           <a:p>
             <a:pPr algn="l">
-              <a:defRPr sz="1100" b="0">
+              <a:defRPr sz="1200" b="0">
                 <a:solidFill>
                   <a:srgbClr val="333333"/>
                 </a:solidFill>
@@ -29712,7 +29712,7 @@
           </a:p>
           <a:p>
             <a:pPr algn="l">
-              <a:defRPr sz="1100" b="0">
+              <a:defRPr sz="1200" b="0">
                 <a:solidFill>
                   <a:srgbClr val="333333"/>
                 </a:solidFill>
@@ -29834,7 +29834,7 @@
           <a:lstStyle/>
           <a:p>
             <a:pPr algn="l">
-              <a:defRPr sz="1100" b="0">
+              <a:defRPr sz="1200" b="0">
                 <a:solidFill>
                   <a:srgbClr val="333333"/>
                 </a:solidFill>
@@ -29847,7 +29847,7 @@
           </a:p>
           <a:p>
             <a:pPr algn="l">
-              <a:defRPr sz="1100" b="0">
+              <a:defRPr sz="1200" b="0">
                 <a:solidFill>
                   <a:srgbClr val="333333"/>
                 </a:solidFill>
@@ -29969,7 +29969,7 @@
           <a:lstStyle/>
           <a:p>
             <a:pPr algn="l">
-              <a:defRPr sz="1100" b="0">
+              <a:defRPr sz="1200" b="0">
                 <a:solidFill>
                   <a:srgbClr val="333333"/>
                 </a:solidFill>
@@ -29982,7 +29982,7 @@
           </a:p>
           <a:p>
             <a:pPr algn="l">
-              <a:defRPr sz="1100" b="0">
+              <a:defRPr sz="1200" b="0">
                 <a:solidFill>
                   <a:srgbClr val="333333"/>
                 </a:solidFill>
@@ -30092,7 +30092,7 @@
       </p:sp>
       <p:pic>
         <p:nvPicPr>
-          <p:cNvPr id="4" name="Picture 3" descr="knu_emblem_official.jpg"/>
+          <p:cNvPr id="4" name="Picture 3" descr="knu_symbol_t.png"/>
           <p:cNvPicPr>
             <a:picLocks noChangeAspect="1"/>
           </p:cNvPicPr>
@@ -31084,7 +31084,7 @@
       </p:sp>
       <p:pic>
         <p:nvPicPr>
-          <p:cNvPr id="3" name="Picture 2" descr="knu_emblem_official.jpg"/>
+          <p:cNvPr id="3" name="Picture 2" descr="knu_symbol_t.png"/>
           <p:cNvPicPr>
             <a:picLocks noChangeAspect="1"/>
           </p:cNvPicPr>
@@ -31539,7 +31539,7 @@
       </p:sp>
       <p:pic>
         <p:nvPicPr>
-          <p:cNvPr id="4" name="Picture 3" descr="knu_emblem_official.jpg"/>
+          <p:cNvPr id="4" name="Picture 3" descr="knu_symbol_t.png"/>
           <p:cNvPicPr>
             <a:picLocks noChangeAspect="1"/>
           </p:cNvPicPr>
@@ -31782,8 +31782,8 @@
         </p:nvSpPr>
         <p:spPr>
           <a:xfrm>
-            <a:off x="548640" y="3383280"/>
-            <a:ext cx="4754880" cy="731520"/>
+            <a:off x="548640" y="3291840"/>
+            <a:ext cx="4754880" cy="685800"/>
           </a:xfrm>
           <a:prstGeom prst="roundRect">
             <a:avLst/>
@@ -31827,7 +31827,7 @@
         </p:nvSpPr>
         <p:spPr>
           <a:xfrm>
-            <a:off x="731520" y="3429000"/>
+            <a:off x="731520" y="3319272"/>
             <a:ext cx="1280160" cy="274320"/>
           </a:xfrm>
           <a:prstGeom prst="rect">
@@ -31861,7 +31861,7 @@
         </p:nvSpPr>
         <p:spPr>
           <a:xfrm>
-            <a:off x="731520" y="3703320"/>
+            <a:off x="731520" y="3575304"/>
             <a:ext cx="3474720" cy="365760"/>
           </a:xfrm>
           <a:prstGeom prst="rect">
@@ -31874,7 +31874,7 @@
           <a:lstStyle/>
           <a:p>
             <a:pPr algn="l">
-              <a:defRPr sz="900" b="0">
+              <a:defRPr sz="1100" b="0">
                 <a:solidFill>
                   <a:srgbClr val="333333"/>
                 </a:solidFill>
@@ -31887,7 +31887,7 @@
           </a:p>
           <a:p>
             <a:pPr algn="l">
-              <a:defRPr sz="900" b="0">
+              <a:defRPr sz="1100" b="0">
                 <a:solidFill>
                   <a:srgbClr val="333333"/>
                 </a:solidFill>
@@ -31908,8 +31908,8 @@
         </p:nvSpPr>
         <p:spPr>
           <a:xfrm>
-            <a:off x="4297680" y="3429000"/>
-            <a:ext cx="914400" cy="640080"/>
+            <a:off x="4297680" y="3319272"/>
+            <a:ext cx="914400" cy="621792"/>
           </a:xfrm>
           <a:prstGeom prst="roundRect">
             <a:avLst/>
@@ -31963,8 +31963,8 @@
         </p:nvSpPr>
         <p:spPr>
           <a:xfrm>
-            <a:off x="548640" y="4206240"/>
-            <a:ext cx="4754880" cy="731520"/>
+            <a:off x="548640" y="4023360"/>
+            <a:ext cx="4754880" cy="685800"/>
           </a:xfrm>
           <a:prstGeom prst="roundRect">
             <a:avLst/>
@@ -32008,7 +32008,7 @@
         </p:nvSpPr>
         <p:spPr>
           <a:xfrm>
-            <a:off x="731520" y="4251960"/>
+            <a:off x="731520" y="4050792"/>
             <a:ext cx="1280160" cy="274320"/>
           </a:xfrm>
           <a:prstGeom prst="rect">
@@ -32042,7 +32042,7 @@
         </p:nvSpPr>
         <p:spPr>
           <a:xfrm>
-            <a:off x="731520" y="4526280"/>
+            <a:off x="731520" y="4306824"/>
             <a:ext cx="3474720" cy="365760"/>
           </a:xfrm>
           <a:prstGeom prst="rect">
@@ -32055,7 +32055,7 @@
           <a:lstStyle/>
           <a:p>
             <a:pPr algn="l">
-              <a:defRPr sz="900" b="0">
+              <a:defRPr sz="1100" b="0">
                 <a:solidFill>
                   <a:srgbClr val="333333"/>
                 </a:solidFill>
@@ -32068,7 +32068,7 @@
           </a:p>
           <a:p>
             <a:pPr algn="l">
-              <a:defRPr sz="900" b="0">
+              <a:defRPr sz="1100" b="0">
                 <a:solidFill>
                   <a:srgbClr val="333333"/>
                 </a:solidFill>
@@ -32089,8 +32089,8 @@
         </p:nvSpPr>
         <p:spPr>
           <a:xfrm>
-            <a:off x="4297680" y="4251960"/>
-            <a:ext cx="914400" cy="640080"/>
+            <a:off x="4297680" y="4050792"/>
+            <a:ext cx="914400" cy="621792"/>
           </a:xfrm>
           <a:prstGeom prst="roundRect">
             <a:avLst/>
@@ -32144,8 +32144,8 @@
         </p:nvSpPr>
         <p:spPr>
           <a:xfrm>
-            <a:off x="548640" y="5029200"/>
-            <a:ext cx="4754880" cy="731520"/>
+            <a:off x="548640" y="4754880"/>
+            <a:ext cx="4754880" cy="685800"/>
           </a:xfrm>
           <a:prstGeom prst="roundRect">
             <a:avLst/>
@@ -32189,7 +32189,7 @@
         </p:nvSpPr>
         <p:spPr>
           <a:xfrm>
-            <a:off x="731520" y="5074920"/>
+            <a:off x="731520" y="4782312"/>
             <a:ext cx="1280160" cy="274320"/>
           </a:xfrm>
           <a:prstGeom prst="rect">
@@ -32223,7 +32223,7 @@
         </p:nvSpPr>
         <p:spPr>
           <a:xfrm>
-            <a:off x="731520" y="5349240"/>
+            <a:off x="731520" y="5038344"/>
             <a:ext cx="3474720" cy="365760"/>
           </a:xfrm>
           <a:prstGeom prst="rect">
@@ -32236,7 +32236,7 @@
           <a:lstStyle/>
           <a:p>
             <a:pPr algn="l">
-              <a:defRPr sz="900" b="0">
+              <a:defRPr sz="1100" b="0">
                 <a:solidFill>
                   <a:srgbClr val="333333"/>
                 </a:solidFill>
@@ -32257,8 +32257,8 @@
         </p:nvSpPr>
         <p:spPr>
           <a:xfrm>
-            <a:off x="4297680" y="5074920"/>
-            <a:ext cx="914400" cy="640080"/>
+            <a:off x="4297680" y="4782312"/>
+            <a:ext cx="914400" cy="621792"/>
           </a:xfrm>
           <a:prstGeom prst="roundRect">
             <a:avLst/>
@@ -32312,8 +32312,8 @@
         </p:nvSpPr>
         <p:spPr>
           <a:xfrm>
-            <a:off x="548640" y="5852160"/>
-            <a:ext cx="4754880" cy="731520"/>
+            <a:off x="548640" y="5486400"/>
+            <a:ext cx="4754880" cy="685800"/>
           </a:xfrm>
           <a:prstGeom prst="roundRect">
             <a:avLst/>
@@ -32357,7 +32357,7 @@
         </p:nvSpPr>
         <p:spPr>
           <a:xfrm>
-            <a:off x="731520" y="5897880"/>
+            <a:off x="731520" y="5513832"/>
             <a:ext cx="1280160" cy="274320"/>
           </a:xfrm>
           <a:prstGeom prst="rect">
@@ -32391,7 +32391,7 @@
         </p:nvSpPr>
         <p:spPr>
           <a:xfrm>
-            <a:off x="731520" y="6172200"/>
+            <a:off x="731520" y="5769864"/>
             <a:ext cx="3474720" cy="365760"/>
           </a:xfrm>
           <a:prstGeom prst="rect">
@@ -32404,7 +32404,7 @@
           <a:lstStyle/>
           <a:p>
             <a:pPr algn="l">
-              <a:defRPr sz="900" b="0">
+              <a:defRPr sz="1100" b="0">
                 <a:solidFill>
                   <a:srgbClr val="333333"/>
                 </a:solidFill>
@@ -32417,7 +32417,7 @@
           </a:p>
           <a:p>
             <a:pPr algn="l">
-              <a:defRPr sz="900" b="0">
+              <a:defRPr sz="1100" b="0">
                 <a:solidFill>
                   <a:srgbClr val="333333"/>
                 </a:solidFill>
@@ -32438,8 +32438,8 @@
         </p:nvSpPr>
         <p:spPr>
           <a:xfrm>
-            <a:off x="4297680" y="5897880"/>
-            <a:ext cx="914400" cy="640080"/>
+            <a:off x="4297680" y="5513832"/>
+            <a:ext cx="914400" cy="621792"/>
           </a:xfrm>
           <a:prstGeom prst="roundRect">
             <a:avLst/>
@@ -32493,7 +32493,7 @@
         </p:nvSpPr>
         <p:spPr>
           <a:xfrm>
-            <a:off x="5669280" y="3383280"/>
+            <a:off x="5669280" y="3291840"/>
             <a:ext cx="1920240" cy="502920"/>
           </a:xfrm>
           <a:prstGeom prst="roundRect">
@@ -32546,7 +32546,7 @@
         </p:nvSpPr>
         <p:spPr>
           <a:xfrm>
-            <a:off x="5760720" y="3977640"/>
+            <a:off x="5760720" y="3886200"/>
             <a:ext cx="1737360" cy="1371600"/>
           </a:xfrm>
           <a:prstGeom prst="roundRect">
@@ -32601,7 +32601,7 @@
         </p:nvSpPr>
         <p:spPr>
           <a:xfrm>
-            <a:off x="7589520" y="3429000"/>
+            <a:off x="7589520" y="3337560"/>
             <a:ext cx="274320" cy="411480"/>
           </a:xfrm>
           <a:prstGeom prst="rect">
@@ -32635,7 +32635,7 @@
         </p:nvSpPr>
         <p:spPr>
           <a:xfrm>
-            <a:off x="7863840" y="3383280"/>
+            <a:off x="7863840" y="3291840"/>
             <a:ext cx="1920240" cy="502920"/>
           </a:xfrm>
           <a:prstGeom prst="roundRect">
@@ -32688,7 +32688,7 @@
         </p:nvSpPr>
         <p:spPr>
           <a:xfrm>
-            <a:off x="7955280" y="3977640"/>
+            <a:off x="7955280" y="3886200"/>
             <a:ext cx="1737360" cy="1371600"/>
           </a:xfrm>
           <a:prstGeom prst="roundRect">
@@ -32743,7 +32743,7 @@
         </p:nvSpPr>
         <p:spPr>
           <a:xfrm>
-            <a:off x="9784080" y="3429000"/>
+            <a:off x="9784080" y="3337560"/>
             <a:ext cx="274320" cy="411480"/>
           </a:xfrm>
           <a:prstGeom prst="rect">
@@ -32777,7 +32777,7 @@
         </p:nvSpPr>
         <p:spPr>
           <a:xfrm>
-            <a:off x="10058400" y="3383280"/>
+            <a:off x="10058400" y="3291840"/>
             <a:ext cx="1920240" cy="502920"/>
           </a:xfrm>
           <a:prstGeom prst="roundRect">
@@ -32830,7 +32830,7 @@
         </p:nvSpPr>
         <p:spPr>
           <a:xfrm>
-            <a:off x="10149840" y="3977640"/>
+            <a:off x="10149840" y="3886200"/>
             <a:ext cx="1737360" cy="1371600"/>
           </a:xfrm>
           <a:prstGeom prst="roundRect">
@@ -32885,7 +32885,7 @@
         </p:nvSpPr>
         <p:spPr>
           <a:xfrm>
-            <a:off x="5669280" y="5577840"/>
+            <a:off x="5669280" y="5394960"/>
             <a:ext cx="5760720" cy="640080"/>
           </a:xfrm>
           <a:prstGeom prst="roundRect">
@@ -33042,7 +33042,7 @@
       </p:sp>
       <p:pic>
         <p:nvPicPr>
-          <p:cNvPr id="4" name="Picture 3" descr="knu_emblem_official.jpg"/>
+          <p:cNvPr id="4" name="Picture 3" descr="knu_symbol_t.png"/>
           <p:cNvPicPr>
             <a:picLocks noChangeAspect="1"/>
           </p:cNvPicPr>
@@ -33328,7 +33328,7 @@
           <a:lstStyle/>
           <a:p>
             <a:pPr algn="l">
-              <a:defRPr sz="900" b="0">
+              <a:defRPr sz="1100" b="0">
                 <a:solidFill>
                   <a:srgbClr val="333333"/>
                 </a:solidFill>
@@ -33439,7 +33439,7 @@
           <a:lstStyle/>
           <a:p>
             <a:pPr algn="l">
-              <a:defRPr sz="900" b="0">
+              <a:defRPr sz="1100" b="0">
                 <a:solidFill>
                   <a:srgbClr val="333333"/>
                 </a:solidFill>
@@ -33550,7 +33550,7 @@
           <a:lstStyle/>
           <a:p>
             <a:pPr algn="l">
-              <a:defRPr sz="900" b="0">
+              <a:defRPr sz="1100" b="0">
                 <a:solidFill>
                   <a:srgbClr val="333333"/>
                 </a:solidFill>
@@ -33740,7 +33740,7 @@
           <a:lstStyle/>
           <a:p>
             <a:pPr algn="l">
-              <a:defRPr sz="900" b="0">
+              <a:defRPr sz="1100" b="0">
                 <a:solidFill>
                   <a:srgbClr val="333333"/>
                 </a:solidFill>
@@ -33896,7 +33896,7 @@
           <a:lstStyle/>
           <a:p>
             <a:pPr algn="l">
-              <a:defRPr sz="900" b="0">
+              <a:defRPr sz="1100" b="0">
                 <a:solidFill>
                   <a:srgbClr val="333333"/>
                 </a:solidFill>
@@ -34052,7 +34052,7 @@
           <a:lstStyle/>
           <a:p>
             <a:pPr algn="l">
-              <a:defRPr sz="900" b="0">
+              <a:defRPr sz="1100" b="0">
                 <a:solidFill>
                   <a:srgbClr val="333333"/>
                 </a:solidFill>
@@ -34243,7 +34243,7 @@
       </p:sp>
       <p:pic>
         <p:nvPicPr>
-          <p:cNvPr id="4" name="Picture 3" descr="knu_emblem_official.jpg"/>
+          <p:cNvPr id="4" name="Picture 3" descr="knu_symbol_t.png"/>
           <p:cNvPicPr>
             <a:picLocks noChangeAspect="1"/>
           </p:cNvPicPr>
@@ -35331,7 +35331,7 @@
       </p:sp>
       <p:pic>
         <p:nvPicPr>
-          <p:cNvPr id="4" name="Picture 3" descr="knu_emblem_official.jpg"/>
+          <p:cNvPr id="4" name="Picture 3" descr="knu_symbol_t.png"/>
           <p:cNvPicPr>
             <a:picLocks noChangeAspect="1"/>
           </p:cNvPicPr>
@@ -35503,51 +35503,48 @@
           <a:bodyPr rtlCol="0" anchor="ctr" wrap="square"/>
           <a:lstStyle/>
           <a:p>
+            <a:pPr algn="ctr"/>
+            <a:r>
+              <a:rPr sz="1300" b="1">
+                <a:solidFill>
+                  <a:srgbClr val="FFFFFF"/>
+                </a:solidFill>
+                <a:latin typeface="Calibri"/>
+              </a:rPr>
+              <a:t>Problem</a:t>
+            </a:r>
+          </a:p>
+          <a:p>
             <a:pPr algn="ctr">
-              <a:defRPr sz="1100" b="0">
+              <a:spcBef>
+                <a:spcPts val="200"/>
+              </a:spcBef>
+              <a:spcAft>
+                <a:spcPts val="0"/>
+              </a:spcAft>
+            </a:pPr>
+          </a:p>
+          <a:p>
+            <a:pPr algn="ctr"/>
+            <a:r>
+              <a:rPr sz="1100" b="0">
                 <a:solidFill>
                   <a:srgbClr val="FFFFFF"/>
                 </a:solidFill>
                 <a:latin typeface="Calibri"/>
-              </a:defRPr>
-            </a:pPr>
-            <a:r>
-              <a:t>Problem</a:t>
-            </a:r>
-          </a:p>
-          <a:p>
-            <a:pPr algn="ctr">
-              <a:defRPr sz="1100" b="0">
+              </a:rPr>
+              <a:t>No benchmark for</a:t>
+            </a:r>
+          </a:p>
+          <a:p>
+            <a:pPr algn="ctr"/>
+            <a:r>
+              <a:rPr sz="1100" b="0">
                 <a:solidFill>
                   <a:srgbClr val="FFFFFF"/>
                 </a:solidFill>
                 <a:latin typeface="Calibri"/>
-              </a:defRPr>
-            </a:pPr>
-          </a:p>
-          <a:p>
-            <a:pPr algn="ctr">
-              <a:defRPr sz="1100" b="0">
-                <a:solidFill>
-                  <a:srgbClr val="FFFFFF"/>
-                </a:solidFill>
-                <a:latin typeface="Calibri"/>
-              </a:defRPr>
-            </a:pPr>
-            <a:r>
-              <a:t>No benchmark for</a:t>
-            </a:r>
-          </a:p>
-          <a:p>
-            <a:pPr algn="ctr">
-              <a:defRPr sz="1100" b="0">
-                <a:solidFill>
-                  <a:srgbClr val="FFFFFF"/>
-                </a:solidFill>
-                <a:latin typeface="Calibri"/>
-              </a:defRPr>
-            </a:pPr>
-            <a:r>
+              </a:rPr>
               <a:t>hotspot detection</a:t>
             </a:r>
           </a:p>
@@ -35556,40 +35553,6 @@
       <p:sp>
         <p:nvSpPr>
           <p:cNvPr id="9" name="TextBox 8"/>
-          <p:cNvSpPr txBox="1"/>
-          <p:nvPr/>
-        </p:nvSpPr>
-        <p:spPr>
-          <a:xfrm>
-            <a:off x="365760" y="1280160"/>
-            <a:ext cx="2011680" cy="320040"/>
-          </a:xfrm>
-          <a:prstGeom prst="rect">
-            <a:avLst/>
-          </a:prstGeom>
-          <a:noFill/>
-        </p:spPr>
-        <p:txBody>
-          <a:bodyPr wrap="square" anchor="t"/>
-          <a:lstStyle/>
-          <a:p>
-            <a:pPr algn="ctr">
-              <a:defRPr sz="1300" b="1">
-                <a:solidFill>
-                  <a:srgbClr val="FFFFFF"/>
-                </a:solidFill>
-                <a:latin typeface="Calibri"/>
-              </a:defRPr>
-            </a:pPr>
-            <a:r>
-              <a:t>Problem</a:t>
-            </a:r>
-          </a:p>
-        </p:txBody>
-      </p:sp>
-      <p:sp>
-        <p:nvSpPr>
-          <p:cNvPr id="10" name="TextBox 9"/>
           <p:cNvSpPr txBox="1"/>
           <p:nvPr/>
         </p:nvSpPr>
@@ -35608,7 +35571,7 @@
           <a:lstStyle/>
           <a:p>
             <a:pPr algn="ctr">
-              <a:defRPr sz="2400" b="1">
+              <a:defRPr sz="1800" b="1">
                 <a:solidFill>
                   <a:srgbClr val="333333"/>
                 </a:solidFill>
@@ -35623,7 +35586,7 @@
       </p:sp>
       <p:sp>
         <p:nvSpPr>
-          <p:cNvPr id="11" name="Rounded Rectangle 10"/>
+          <p:cNvPr id="10" name="Rounded Rectangle 9"/>
           <p:cNvSpPr/>
           <p:nvPr/>
         </p:nvSpPr>
@@ -35660,64 +35623,60 @@
           <a:bodyPr rtlCol="0" anchor="ctr" wrap="square"/>
           <a:lstStyle/>
           <a:p>
+            <a:pPr algn="ctr"/>
+            <a:r>
+              <a:rPr sz="1300" b="1">
+                <a:solidFill>
+                  <a:srgbClr val="FFFFFF"/>
+                </a:solidFill>
+                <a:latin typeface="Calibri"/>
+              </a:rPr>
+              <a:t>MutBench</a:t>
+            </a:r>
+          </a:p>
+          <a:p>
             <a:pPr algn="ctr">
-              <a:defRPr sz="1100" b="0">
+              <a:spcBef>
+                <a:spcPts val="200"/>
+              </a:spcBef>
+              <a:spcAft>
+                <a:spcPts val="0"/>
+              </a:spcAft>
+            </a:pPr>
+          </a:p>
+          <a:p>
+            <a:pPr algn="ctr"/>
+            <a:r>
+              <a:rPr sz="1100" b="0">
                 <a:solidFill>
                   <a:srgbClr val="FFFFFF"/>
                 </a:solidFill>
                 <a:latin typeface="Calibri"/>
-              </a:defRPr>
-            </a:pPr>
-            <a:r>
-              <a:t>MutBench</a:t>
-            </a:r>
-          </a:p>
-          <a:p>
-            <a:pPr algn="ctr">
-              <a:defRPr sz="1100" b="0">
+              </a:rPr>
+              <a:t>3-Layer GT</a:t>
+            </a:r>
+          </a:p>
+          <a:p>
+            <a:pPr algn="ctr"/>
+            <a:r>
+              <a:rPr sz="1100" b="0">
                 <a:solidFill>
                   <a:srgbClr val="FFFFFF"/>
                 </a:solidFill>
                 <a:latin typeface="Calibri"/>
-              </a:defRPr>
-            </a:pPr>
-          </a:p>
-          <a:p>
-            <a:pPr algn="ctr">
-              <a:defRPr sz="1100" b="0">
+              </a:rPr>
+              <a:t>9 Scoring</a:t>
+            </a:r>
+          </a:p>
+          <a:p>
+            <a:pPr algn="ctr"/>
+            <a:r>
+              <a:rPr sz="1100" b="0">
                 <a:solidFill>
                   <a:srgbClr val="FFFFFF"/>
                 </a:solidFill>
                 <a:latin typeface="Calibri"/>
-              </a:defRPr>
-            </a:pPr>
-            <a:r>
-              <a:t>3-Layer GT</a:t>
-            </a:r>
-          </a:p>
-          <a:p>
-            <a:pPr algn="ctr">
-              <a:defRPr sz="1100" b="0">
-                <a:solidFill>
-                  <a:srgbClr val="FFFFFF"/>
-                </a:solidFill>
-                <a:latin typeface="Calibri"/>
-              </a:defRPr>
-            </a:pPr>
-            <a:r>
-              <a:t>9 Scoring</a:t>
-            </a:r>
-          </a:p>
-          <a:p>
-            <a:pPr algn="ctr">
-              <a:defRPr sz="1100" b="0">
-                <a:solidFill>
-                  <a:srgbClr val="FFFFFF"/>
-                </a:solidFill>
-                <a:latin typeface="Calibri"/>
-              </a:defRPr>
-            </a:pPr>
-            <a:r>
+              </a:rPr>
               <a:t>39 Detection</a:t>
             </a:r>
           </a:p>
@@ -35725,41 +35684,7 @@
       </p:sp>
       <p:sp>
         <p:nvSpPr>
-          <p:cNvPr id="12" name="TextBox 11"/>
-          <p:cNvSpPr txBox="1"/>
-          <p:nvPr/>
-        </p:nvSpPr>
-        <p:spPr>
-          <a:xfrm>
-            <a:off x="2743200" y="1280160"/>
-            <a:ext cx="2011680" cy="320040"/>
-          </a:xfrm>
-          <a:prstGeom prst="rect">
-            <a:avLst/>
-          </a:prstGeom>
-          <a:noFill/>
-        </p:spPr>
-        <p:txBody>
-          <a:bodyPr wrap="square" anchor="t"/>
-          <a:lstStyle/>
-          <a:p>
-            <a:pPr algn="ctr">
-              <a:defRPr sz="1300" b="1">
-                <a:solidFill>
-                  <a:srgbClr val="FFFFFF"/>
-                </a:solidFill>
-                <a:latin typeface="Calibri"/>
-              </a:defRPr>
-            </a:pPr>
-            <a:r>
-              <a:t>MutBench</a:t>
-            </a:r>
-          </a:p>
-        </p:txBody>
-      </p:sp>
-      <p:sp>
-        <p:nvSpPr>
-          <p:cNvPr id="13" name="TextBox 12"/>
+          <p:cNvPr id="11" name="TextBox 10"/>
           <p:cNvSpPr txBox="1"/>
           <p:nvPr/>
         </p:nvSpPr>
@@ -35778,7 +35703,7 @@
           <a:lstStyle/>
           <a:p>
             <a:pPr algn="ctr">
-              <a:defRPr sz="2400" b="1">
+              <a:defRPr sz="1800" b="1">
                 <a:solidFill>
                   <a:srgbClr val="333333"/>
                 </a:solidFill>
@@ -35793,7 +35718,7 @@
       </p:sp>
       <p:sp>
         <p:nvSpPr>
-          <p:cNvPr id="14" name="Rounded Rectangle 13"/>
+          <p:cNvPr id="12" name="Rounded Rectangle 11"/>
           <p:cNvSpPr/>
           <p:nvPr/>
         </p:nvSpPr>
@@ -35830,51 +35755,48 @@
           <a:bodyPr rtlCol="0" anchor="ctr" wrap="square"/>
           <a:lstStyle/>
           <a:p>
+            <a:pPr algn="ctr"/>
+            <a:r>
+              <a:rPr sz="1300" b="1">
+                <a:solidFill>
+                  <a:srgbClr val="FFFFFF"/>
+                </a:solidFill>
+                <a:latin typeface="Calibri"/>
+              </a:rPr>
+              <a:t>Stage 1</a:t>
+            </a:r>
+          </a:p>
+          <a:p>
             <a:pPr algn="ctr">
-              <a:defRPr sz="1100" b="0">
+              <a:spcBef>
+                <a:spcPts val="200"/>
+              </a:spcBef>
+              <a:spcAft>
+                <a:spcPts val="0"/>
+              </a:spcAft>
+            </a:pPr>
+          </a:p>
+          <a:p>
+            <a:pPr algn="ctr"/>
+            <a:r>
+              <a:rPr sz="1100" b="0">
                 <a:solidFill>
                   <a:srgbClr val="FFFFFF"/>
                 </a:solidFill>
                 <a:latin typeface="Calibri"/>
-              </a:defRPr>
-            </a:pPr>
-            <a:r>
-              <a:t>Stage 1</a:t>
-            </a:r>
-          </a:p>
-          <a:p>
-            <a:pPr algn="ctr">
-              <a:defRPr sz="1100" b="0">
+              </a:rPr>
+              <a:t>SARS-CoV-2</a:t>
+            </a:r>
+          </a:p>
+          <a:p>
+            <a:pPr algn="ctr"/>
+            <a:r>
+              <a:rPr sz="1100" b="0">
                 <a:solidFill>
                   <a:srgbClr val="FFFFFF"/>
                 </a:solidFill>
                 <a:latin typeface="Calibri"/>
-              </a:defRPr>
-            </a:pPr>
-          </a:p>
-          <a:p>
-            <a:pPr algn="ctr">
-              <a:defRPr sz="1100" b="0">
-                <a:solidFill>
-                  <a:srgbClr val="FFFFFF"/>
-                </a:solidFill>
-                <a:latin typeface="Calibri"/>
-              </a:defRPr>
-            </a:pPr>
-            <a:r>
-              <a:t>SARS-CoV-2</a:t>
-            </a:r>
-          </a:p>
-          <a:p>
-            <a:pPr algn="ctr">
-              <a:defRPr sz="1100" b="0">
-                <a:solidFill>
-                  <a:srgbClr val="FFFFFF"/>
-                </a:solidFill>
-                <a:latin typeface="Calibri"/>
-              </a:defRPr>
-            </a:pPr>
-            <a:r>
+              </a:rPr>
               <a:t>depth analysis</a:t>
             </a:r>
           </a:p>
@@ -35882,41 +35804,7 @@
       </p:sp>
       <p:sp>
         <p:nvSpPr>
-          <p:cNvPr id="15" name="TextBox 14"/>
-          <p:cNvSpPr txBox="1"/>
-          <p:nvPr/>
-        </p:nvSpPr>
-        <p:spPr>
-          <a:xfrm>
-            <a:off x="5120640" y="1280160"/>
-            <a:ext cx="2011680" cy="320040"/>
-          </a:xfrm>
-          <a:prstGeom prst="rect">
-            <a:avLst/>
-          </a:prstGeom>
-          <a:noFill/>
-        </p:spPr>
-        <p:txBody>
-          <a:bodyPr wrap="square" anchor="t"/>
-          <a:lstStyle/>
-          <a:p>
-            <a:pPr algn="ctr">
-              <a:defRPr sz="1300" b="1">
-                <a:solidFill>
-                  <a:srgbClr val="FFFFFF"/>
-                </a:solidFill>
-                <a:latin typeface="Calibri"/>
-              </a:defRPr>
-            </a:pPr>
-            <a:r>
-              <a:t>Stage 1</a:t>
-            </a:r>
-          </a:p>
-        </p:txBody>
-      </p:sp>
-      <p:sp>
-        <p:nvSpPr>
-          <p:cNvPr id="16" name="TextBox 15"/>
+          <p:cNvPr id="13" name="TextBox 12"/>
           <p:cNvSpPr txBox="1"/>
           <p:nvPr/>
         </p:nvSpPr>
@@ -35935,7 +35823,7 @@
           <a:lstStyle/>
           <a:p>
             <a:pPr algn="ctr">
-              <a:defRPr sz="2400" b="1">
+              <a:defRPr sz="1800" b="1">
                 <a:solidFill>
                   <a:srgbClr val="333333"/>
                 </a:solidFill>
@@ -35950,7 +35838,7 @@
       </p:sp>
       <p:sp>
         <p:nvSpPr>
-          <p:cNvPr id="17" name="Rounded Rectangle 16"/>
+          <p:cNvPr id="14" name="Rounded Rectangle 13"/>
           <p:cNvSpPr/>
           <p:nvPr/>
         </p:nvSpPr>
@@ -35987,51 +35875,48 @@
           <a:bodyPr rtlCol="0" anchor="ctr" wrap="square"/>
           <a:lstStyle/>
           <a:p>
+            <a:pPr algn="ctr"/>
+            <a:r>
+              <a:rPr sz="1300" b="1">
+                <a:solidFill>
+                  <a:srgbClr val="FFFFFF"/>
+                </a:solidFill>
+                <a:latin typeface="Calibri"/>
+              </a:rPr>
+              <a:t>Stage 2</a:t>
+            </a:r>
+          </a:p>
+          <a:p>
             <a:pPr algn="ctr">
-              <a:defRPr sz="1100" b="0">
+              <a:spcBef>
+                <a:spcPts val="200"/>
+              </a:spcBef>
+              <a:spcAft>
+                <a:spcPts val="0"/>
+              </a:spcAft>
+            </a:pPr>
+          </a:p>
+          <a:p>
+            <a:pPr algn="ctr"/>
+            <a:r>
+              <a:rPr sz="1100" b="0">
                 <a:solidFill>
                   <a:srgbClr val="FFFFFF"/>
                 </a:solidFill>
                 <a:latin typeface="Calibri"/>
-              </a:defRPr>
-            </a:pPr>
-            <a:r>
-              <a:t>Stage 2</a:t>
-            </a:r>
-          </a:p>
-          <a:p>
-            <a:pPr algn="ctr">
-              <a:defRPr sz="1100" b="0">
+              </a:rPr>
+              <a:t>9 pathogens</a:t>
+            </a:r>
+          </a:p>
+          <a:p>
+            <a:pPr algn="ctr"/>
+            <a:r>
+              <a:rPr sz="1100" b="0">
                 <a:solidFill>
                   <a:srgbClr val="FFFFFF"/>
                 </a:solidFill>
                 <a:latin typeface="Calibri"/>
-              </a:defRPr>
-            </a:pPr>
-          </a:p>
-          <a:p>
-            <a:pPr algn="ctr">
-              <a:defRPr sz="1100" b="0">
-                <a:solidFill>
-                  <a:srgbClr val="FFFFFF"/>
-                </a:solidFill>
-                <a:latin typeface="Calibri"/>
-              </a:defRPr>
-            </a:pPr>
-            <a:r>
-              <a:t>9 pathogens</a:t>
-            </a:r>
-          </a:p>
-          <a:p>
-            <a:pPr algn="ctr">
-              <a:defRPr sz="1100" b="0">
-                <a:solidFill>
-                  <a:srgbClr val="FFFFFF"/>
-                </a:solidFill>
-                <a:latin typeface="Calibri"/>
-              </a:defRPr>
-            </a:pPr>
-            <a:r>
+              </a:rPr>
               <a:t>2,544 evaluations</a:t>
             </a:r>
           </a:p>
@@ -36039,41 +35924,7 @@
       </p:sp>
       <p:sp>
         <p:nvSpPr>
-          <p:cNvPr id="18" name="TextBox 17"/>
-          <p:cNvSpPr txBox="1"/>
-          <p:nvPr/>
-        </p:nvSpPr>
-        <p:spPr>
-          <a:xfrm>
-            <a:off x="7498080" y="1280160"/>
-            <a:ext cx="2011680" cy="320040"/>
-          </a:xfrm>
-          <a:prstGeom prst="rect">
-            <a:avLst/>
-          </a:prstGeom>
-          <a:noFill/>
-        </p:spPr>
-        <p:txBody>
-          <a:bodyPr wrap="square" anchor="t"/>
-          <a:lstStyle/>
-          <a:p>
-            <a:pPr algn="ctr">
-              <a:defRPr sz="1300" b="1">
-                <a:solidFill>
-                  <a:srgbClr val="FFFFFF"/>
-                </a:solidFill>
-                <a:latin typeface="Calibri"/>
-              </a:defRPr>
-            </a:pPr>
-            <a:r>
-              <a:t>Stage 2</a:t>
-            </a:r>
-          </a:p>
-        </p:txBody>
-      </p:sp>
-      <p:sp>
-        <p:nvSpPr>
-          <p:cNvPr id="19" name="TextBox 18"/>
+          <p:cNvPr id="15" name="TextBox 14"/>
           <p:cNvSpPr txBox="1"/>
           <p:nvPr/>
         </p:nvSpPr>
@@ -36092,7 +35943,7 @@
           <a:lstStyle/>
           <a:p>
             <a:pPr algn="ctr">
-              <a:defRPr sz="2400" b="1">
+              <a:defRPr sz="1800" b="1">
                 <a:solidFill>
                   <a:srgbClr val="333333"/>
                 </a:solidFill>
@@ -36107,7 +35958,7 @@
       </p:sp>
       <p:sp>
         <p:nvSpPr>
-          <p:cNvPr id="20" name="Rounded Rectangle 19"/>
+          <p:cNvPr id="16" name="Rounded Rectangle 15"/>
           <p:cNvSpPr/>
           <p:nvPr/>
         </p:nvSpPr>
@@ -36144,51 +35995,48 @@
           <a:bodyPr rtlCol="0" anchor="ctr" wrap="square"/>
           <a:lstStyle/>
           <a:p>
+            <a:pPr algn="ctr"/>
+            <a:r>
+              <a:rPr sz="1300" b="1">
+                <a:solidFill>
+                  <a:srgbClr val="FFFFFF"/>
+                </a:solidFill>
+                <a:latin typeface="Calibri"/>
+              </a:rPr>
+              <a:t>Finding</a:t>
+            </a:r>
+          </a:p>
+          <a:p>
             <a:pPr algn="ctr">
-              <a:defRPr sz="1100" b="0">
+              <a:spcBef>
+                <a:spcPts val="200"/>
+              </a:spcBef>
+              <a:spcAft>
+                <a:spcPts val="0"/>
+              </a:spcAft>
+            </a:pPr>
+          </a:p>
+          <a:p>
+            <a:pPr algn="ctr"/>
+            <a:r>
+              <a:rPr sz="1100" b="0">
                 <a:solidFill>
                   <a:srgbClr val="FFFFFF"/>
                 </a:solidFill>
                 <a:latin typeface="Calibri"/>
-              </a:defRPr>
-            </a:pPr>
-            <a:r>
-              <a:t>Finding</a:t>
-            </a:r>
-          </a:p>
-          <a:p>
-            <a:pPr algn="ctr">
-              <a:defRPr sz="1100" b="0">
+              </a:rPr>
+              <a:t>No universal best</a:t>
+            </a:r>
+          </a:p>
+          <a:p>
+            <a:pPr algn="ctr"/>
+            <a:r>
+              <a:rPr sz="1100" b="0">
                 <a:solidFill>
                   <a:srgbClr val="FFFFFF"/>
                 </a:solidFill>
                 <a:latin typeface="Calibri"/>
-              </a:defRPr>
-            </a:pPr>
-          </a:p>
-          <a:p>
-            <a:pPr algn="ctr">
-              <a:defRPr sz="1100" b="0">
-                <a:solidFill>
-                  <a:srgbClr val="FFFFFF"/>
-                </a:solidFill>
-                <a:latin typeface="Calibri"/>
-              </a:defRPr>
-            </a:pPr>
-            <a:r>
-              <a:t>No universal best</a:t>
-            </a:r>
-          </a:p>
-          <a:p>
-            <a:pPr algn="ctr">
-              <a:defRPr sz="1100" b="0">
-                <a:solidFill>
-                  <a:srgbClr val="FFFFFF"/>
-                </a:solidFill>
-                <a:latin typeface="Calibri"/>
-              </a:defRPr>
-            </a:pPr>
-            <a:r>
+              </a:rPr>
               <a:t>ω² = 0.285</a:t>
             </a:r>
           </a:p>
@@ -36196,41 +36044,7 @@
       </p:sp>
       <p:sp>
         <p:nvSpPr>
-          <p:cNvPr id="21" name="TextBox 20"/>
-          <p:cNvSpPr txBox="1"/>
-          <p:nvPr/>
-        </p:nvSpPr>
-        <p:spPr>
-          <a:xfrm>
-            <a:off x="9875520" y="1280160"/>
-            <a:ext cx="2011680" cy="320040"/>
-          </a:xfrm>
-          <a:prstGeom prst="rect">
-            <a:avLst/>
-          </a:prstGeom>
-          <a:noFill/>
-        </p:spPr>
-        <p:txBody>
-          <a:bodyPr wrap="square" anchor="t"/>
-          <a:lstStyle/>
-          <a:p>
-            <a:pPr algn="ctr">
-              <a:defRPr sz="1300" b="1">
-                <a:solidFill>
-                  <a:srgbClr val="FFFFFF"/>
-                </a:solidFill>
-                <a:latin typeface="Calibri"/>
-              </a:defRPr>
-            </a:pPr>
-            <a:r>
-              <a:t>Finding</a:t>
-            </a:r>
-          </a:p>
-        </p:txBody>
-      </p:sp>
-      <p:sp>
-        <p:nvSpPr>
-          <p:cNvPr id="22" name="Rectangle 21"/>
+          <p:cNvPr id="17" name="Rectangle 16"/>
           <p:cNvSpPr/>
           <p:nvPr/>
         </p:nvSpPr>
@@ -36273,7 +36087,7 @@
       </p:sp>
       <p:sp>
         <p:nvSpPr>
-          <p:cNvPr id="23" name="TextBox 22"/>
+          <p:cNvPr id="18" name="TextBox 17"/>
           <p:cNvSpPr txBox="1"/>
           <p:nvPr/>
         </p:nvSpPr>
@@ -36307,7 +36121,7 @@
       </p:sp>
       <p:sp>
         <p:nvSpPr>
-          <p:cNvPr id="24" name="Rounded Rectangle 23"/>
+          <p:cNvPr id="19" name="Rounded Rectangle 18"/>
           <p:cNvSpPr/>
           <p:nvPr/>
         </p:nvSpPr>
@@ -36373,7 +36187,7 @@
       </p:sp>
       <p:sp>
         <p:nvSpPr>
-          <p:cNvPr id="25" name="Rounded Rectangle 24"/>
+          <p:cNvPr id="20" name="Rounded Rectangle 19"/>
           <p:cNvSpPr/>
           <p:nvPr/>
         </p:nvSpPr>
@@ -36418,7 +36232,7 @@
       </p:sp>
       <p:sp>
         <p:nvSpPr>
-          <p:cNvPr id="26" name="TextBox 25"/>
+          <p:cNvPr id="21" name="TextBox 20"/>
           <p:cNvSpPr txBox="1"/>
           <p:nvPr/>
         </p:nvSpPr>
@@ -36452,7 +36266,7 @@
       </p:sp>
       <p:sp>
         <p:nvSpPr>
-          <p:cNvPr id="27" name="TextBox 26"/>
+          <p:cNvPr id="22" name="TextBox 21"/>
           <p:cNvSpPr txBox="1"/>
           <p:nvPr/>
         </p:nvSpPr>
@@ -36486,7 +36300,7 @@
       </p:sp>
       <p:sp>
         <p:nvSpPr>
-          <p:cNvPr id="28" name="Rounded Rectangle 27"/>
+          <p:cNvPr id="23" name="Rounded Rectangle 22"/>
           <p:cNvSpPr/>
           <p:nvPr/>
         </p:nvSpPr>
@@ -36531,7 +36345,7 @@
       </p:sp>
       <p:sp>
         <p:nvSpPr>
-          <p:cNvPr id="29" name="TextBox 28"/>
+          <p:cNvPr id="24" name="TextBox 23"/>
           <p:cNvSpPr txBox="1"/>
           <p:nvPr/>
         </p:nvSpPr>
@@ -36565,7 +36379,7 @@
       </p:sp>
       <p:sp>
         <p:nvSpPr>
-          <p:cNvPr id="30" name="TextBox 29"/>
+          <p:cNvPr id="25" name="TextBox 24"/>
           <p:cNvSpPr txBox="1"/>
           <p:nvPr/>
         </p:nvSpPr>
@@ -36599,7 +36413,7 @@
       </p:sp>
       <p:sp>
         <p:nvSpPr>
-          <p:cNvPr id="31" name="Rounded Rectangle 30"/>
+          <p:cNvPr id="26" name="Rounded Rectangle 25"/>
           <p:cNvSpPr/>
           <p:nvPr/>
         </p:nvSpPr>
@@ -36644,7 +36458,7 @@
       </p:sp>
       <p:sp>
         <p:nvSpPr>
-          <p:cNvPr id="32" name="TextBox 31"/>
+          <p:cNvPr id="27" name="TextBox 26"/>
           <p:cNvSpPr txBox="1"/>
           <p:nvPr/>
         </p:nvSpPr>
@@ -36678,7 +36492,7 @@
       </p:sp>
       <p:sp>
         <p:nvSpPr>
-          <p:cNvPr id="33" name="TextBox 32"/>
+          <p:cNvPr id="28" name="TextBox 27"/>
           <p:cNvSpPr txBox="1"/>
           <p:nvPr/>
         </p:nvSpPr>
@@ -36712,7 +36526,7 @@
       </p:sp>
       <p:sp>
         <p:nvSpPr>
-          <p:cNvPr id="34" name="Rounded Rectangle 33"/>
+          <p:cNvPr id="29" name="Rounded Rectangle 28"/>
           <p:cNvSpPr/>
           <p:nvPr/>
         </p:nvSpPr>
@@ -36757,7 +36571,7 @@
       </p:sp>
       <p:sp>
         <p:nvSpPr>
-          <p:cNvPr id="35" name="TextBox 34"/>
+          <p:cNvPr id="30" name="TextBox 29"/>
           <p:cNvSpPr txBox="1"/>
           <p:nvPr/>
         </p:nvSpPr>
@@ -36791,7 +36605,7 @@
       </p:sp>
       <p:sp>
         <p:nvSpPr>
-          <p:cNvPr id="36" name="TextBox 35"/>
+          <p:cNvPr id="31" name="TextBox 30"/>
           <p:cNvSpPr txBox="1"/>
           <p:nvPr/>
         </p:nvSpPr>
@@ -36825,7 +36639,7 @@
       </p:sp>
       <p:sp>
         <p:nvSpPr>
-          <p:cNvPr id="37" name="Rounded Rectangle 36"/>
+          <p:cNvPr id="32" name="Rounded Rectangle 31"/>
           <p:cNvSpPr/>
           <p:nvPr/>
         </p:nvSpPr>
@@ -36870,7 +36684,7 @@
       </p:sp>
       <p:sp>
         <p:nvSpPr>
-          <p:cNvPr id="38" name="TextBox 37"/>
+          <p:cNvPr id="33" name="TextBox 32"/>
           <p:cNvSpPr txBox="1"/>
           <p:nvPr/>
         </p:nvSpPr>
@@ -36904,7 +36718,7 @@
       </p:sp>
       <p:sp>
         <p:nvSpPr>
-          <p:cNvPr id="39" name="TextBox 38"/>
+          <p:cNvPr id="34" name="TextBox 33"/>
           <p:cNvSpPr txBox="1"/>
           <p:nvPr/>
         </p:nvSpPr>
@@ -37033,7 +36847,7 @@
       </p:sp>
       <p:pic>
         <p:nvPicPr>
-          <p:cNvPr id="4" name="Picture 3" descr="knu_emblem_official.jpg"/>
+          <p:cNvPr id="4" name="Picture 3" descr="knu_symbol_t.png"/>
           <p:cNvPicPr>
             <a:picLocks noChangeAspect="1"/>
           </p:cNvPicPr>
@@ -37428,7 +37242,7 @@
           <a:lstStyle/>
           <a:p>
             <a:pPr algn="l">
-              <a:defRPr sz="900" b="0">
+              <a:defRPr sz="1100" b="0">
                 <a:solidFill>
                   <a:srgbClr val="333333"/>
                 </a:solidFill>
@@ -37441,7 +37255,7 @@
           </a:p>
           <a:p>
             <a:pPr algn="l">
-              <a:defRPr sz="900" b="0">
+              <a:defRPr sz="1100" b="0">
                 <a:solidFill>
                   <a:srgbClr val="333333"/>
                 </a:solidFill>
@@ -37454,7 +37268,7 @@
           </a:p>
           <a:p>
             <a:pPr algn="l">
-              <a:defRPr sz="900" b="0">
+              <a:defRPr sz="1100" b="0">
                 <a:solidFill>
                   <a:srgbClr val="333333"/>
                 </a:solidFill>
@@ -37567,7 +37381,7 @@
           <a:lstStyle/>
           <a:p>
             <a:pPr algn="l">
-              <a:defRPr sz="900" b="0">
+              <a:defRPr sz="1100" b="0">
                 <a:solidFill>
                   <a:srgbClr val="333333"/>
                 </a:solidFill>
@@ -37580,7 +37394,7 @@
           </a:p>
           <a:p>
             <a:pPr algn="l">
-              <a:defRPr sz="900" b="0">
+              <a:defRPr sz="1100" b="0">
                 <a:solidFill>
                   <a:srgbClr val="333333"/>
                 </a:solidFill>
@@ -37593,7 +37407,7 @@
           </a:p>
           <a:p>
             <a:pPr algn="l">
-              <a:defRPr sz="900" b="0">
+              <a:defRPr sz="1100" b="0">
                 <a:solidFill>
                   <a:srgbClr val="333333"/>
                 </a:solidFill>
@@ -37706,7 +37520,7 @@
           <a:lstStyle/>
           <a:p>
             <a:pPr algn="l">
-              <a:defRPr sz="900" b="0">
+              <a:defRPr sz="1100" b="0">
                 <a:solidFill>
                   <a:srgbClr val="333333"/>
                 </a:solidFill>
@@ -37719,7 +37533,7 @@
           </a:p>
           <a:p>
             <a:pPr algn="l">
-              <a:defRPr sz="900" b="0">
+              <a:defRPr sz="1100" b="0">
                 <a:solidFill>
                   <a:srgbClr val="333333"/>
                 </a:solidFill>
@@ -37732,7 +37546,7 @@
           </a:p>
           <a:p>
             <a:pPr algn="l">
-              <a:defRPr sz="900" b="0">
+              <a:defRPr sz="1100" b="0">
                 <a:solidFill>
                   <a:srgbClr val="333333"/>
                 </a:solidFill>
@@ -37897,7 +37711,7 @@
       </p:sp>
       <p:pic>
         <p:nvPicPr>
-          <p:cNvPr id="4" name="Picture 3" descr="knu_emblem_official.jpg"/>
+          <p:cNvPr id="4" name="Picture 3" descr="knu_symbol_t.png"/>
           <p:cNvPicPr>
             <a:picLocks noChangeAspect="1"/>
           </p:cNvPicPr>

</xml_diff>